<commit_message>
cai_tien: deck 5p — slide mô hình thành bảng so sánh hạn chế↔lựa chọn
Gộp 4 hạn chế paper gốc vào slide kiến trúc: bảng 2 cột
"Hạn chế MedRegA ↔ Lựa chọn của nhóm (vì sao)", mỗi lựa chọn vá
1 hạn chế. Bỏ chart IoU (số 0.015→0.27 gộp vào dòng đầu). EN + VN.

Co-Authored-By: Claude Opus 4.8 <noreply@anthropic.com>
</commit_message>
<xml_diff>
--- a/seminar/cai_tien/slides_5min_EN.pptx
+++ b/seminar/cai_tien/slides_5min_EN.pptx
@@ -3367,7 +3367,7 @@
         <p:spPr>
           <a:xfrm>
             <a:off x="0" y="0"/>
-            <a:ext cx="9144000" cy="886968"/>
+            <a:ext cx="9144000" cy="1188720"/>
           </a:xfrm>
           <a:prstGeom prst="rect">
             <a:avLst/>
@@ -3410,7 +3410,7 @@
         </p:nvSpPr>
         <p:spPr>
           <a:xfrm>
-            <a:off x="320040" y="182880"/>
+            <a:off x="320040" y="109728"/>
             <a:ext cx="8503920" cy="548640"/>
           </a:xfrm>
           <a:prstGeom prst="rect">
@@ -3444,8 +3444,8 @@
         </p:nvSpPr>
         <p:spPr>
           <a:xfrm>
-            <a:off x="365760" y="1024127"/>
-            <a:ext cx="5120640" cy="3291840"/>
+            <a:off x="338328" y="694944"/>
+            <a:ext cx="8412480" cy="411480"/>
           </a:xfrm>
           <a:prstGeom prst="rect">
             <a:avLst/>
@@ -3458,343 +3458,430 @@
           </a:bodyPr>
           <a:lstStyle/>
           <a:p>
-            <a:pPr>
-              <a:spcBef>
-                <a:spcPts val="0"/>
-              </a:spcBef>
-              <a:spcAft>
-                <a:spcPts val="1100"/>
-              </a:spcAft>
-            </a:pPr>
-            <a:r>
-              <a:rPr sz="1350" b="1" i="0">
+            <a:r>
+              <a:rPr sz="1150" b="0" i="1">
                 <a:solidFill>
-                  <a:srgbClr val="1A3A5C"/>
+                  <a:srgbClr val="B8CFE0"/>
                 </a:solidFill>
                 <a:latin typeface="Calibri"/>
               </a:rPr>
-              <a:t>▪  </a:t>
-            </a:r>
-            <a:r>
-              <a:rPr sz="1350" b="1" i="0">
-                <a:solidFill>
-                  <a:srgbClr val="1C2736"/>
-                </a:solidFill>
-                <a:latin typeface="Calibri"/>
-              </a:rPr>
-              <a:t>Backbone:</a:t>
-            </a:r>
-            <a:r>
-              <a:rPr sz="1350" b="0" i="0">
-                <a:solidFill>
-                  <a:srgbClr val="1C2736"/>
-                </a:solidFill>
-                <a:latin typeface="Calibri"/>
-              </a:rPr>
-              <a:t> Gemma 4 E4B (~8B) — 5× smaller than MedRegA (~40B), runs on </a:t>
-            </a:r>
-            <a:r>
-              <a:rPr sz="1350" b="1" i="0">
-                <a:solidFill>
-                  <a:srgbClr val="1C2736"/>
-                </a:solidFill>
-                <a:latin typeface="Calibri"/>
-              </a:rPr>
-              <a:t>1 GPU</a:t>
-            </a:r>
-            <a:r>
-              <a:rPr sz="1350" b="0" i="0">
-                <a:solidFill>
-                  <a:srgbClr val="1C2736"/>
-                </a:solidFill>
-                <a:latin typeface="Calibri"/>
-              </a:rPr>
-              <a:t>; </a:t>
-            </a:r>
-            <a:r>
-              <a:rPr sz="1350" b="1" i="0">
-                <a:solidFill>
-                  <a:srgbClr val="1C2736"/>
-                </a:solidFill>
-                <a:latin typeface="Calibri"/>
-              </a:rPr>
-              <a:t>unlock the vision tower</a:t>
-            </a:r>
-            <a:r>
-              <a:rPr sz="1350" b="0" i="0">
-                <a:solidFill>
-                  <a:srgbClr val="1C2736"/>
-                </a:solidFill>
-                <a:latin typeface="Calibri"/>
-              </a:rPr>
-              <a:t> to learn medical features.</a:t>
-            </a:r>
-          </a:p>
-          <a:p>
-            <a:pPr>
-              <a:spcBef>
-                <a:spcPts val="0"/>
-              </a:spcBef>
-              <a:spcAft>
-                <a:spcPts val="1100"/>
-              </a:spcAft>
-            </a:pPr>
-            <a:r>
-              <a:rPr sz="1350" b="1" i="0">
-                <a:solidFill>
-                  <a:srgbClr val="1A3A5C"/>
-                </a:solidFill>
-                <a:latin typeface="Calibri"/>
-              </a:rPr>
-              <a:t>▪  </a:t>
-            </a:r>
-            <a:r>
-              <a:rPr sz="1350" b="1" i="0">
-                <a:solidFill>
-                  <a:srgbClr val="1C2736"/>
-                </a:solidFill>
-                <a:latin typeface="Calibri"/>
-              </a:rPr>
-              <a:t>Data:</a:t>
-            </a:r>
-            <a:r>
-              <a:rPr sz="1350" b="0" i="0">
-                <a:solidFill>
-                  <a:srgbClr val="1C2736"/>
-                </a:solidFill>
-                <a:latin typeface="Calibri"/>
-              </a:rPr>
-              <a:t> multi-slice + </a:t>
-            </a:r>
-            <a:r>
-              <a:rPr sz="1350" b="1" i="0">
-                <a:solidFill>
-                  <a:srgbClr val="1C2736"/>
-                </a:solidFill>
-                <a:latin typeface="Calibri"/>
-              </a:rPr>
-              <a:t>negatives</a:t>
-            </a:r>
-            <a:r>
-              <a:rPr sz="1350" b="0" i="0">
-                <a:solidFill>
-                  <a:srgbClr val="1C2736"/>
-                </a:solidFill>
-                <a:latin typeface="Calibri"/>
-              </a:rPr>
-              <a:t> (no tumor) + </a:t>
-            </a:r>
-            <a:r>
-              <a:rPr sz="1350" b="1" i="0">
-                <a:solidFill>
-                  <a:srgbClr val="1C2736"/>
-                </a:solidFill>
-                <a:latin typeface="Calibri"/>
-              </a:rPr>
-              <a:t>multi-box</a:t>
-            </a:r>
-            <a:r>
-              <a:rPr sz="1350" b="0" i="0">
-                <a:solidFill>
-                  <a:srgbClr val="1C2736"/>
-                </a:solidFill>
-                <a:latin typeface="Calibri"/>
-              </a:rPr>
-              <a:t> (per-lesion) — vs paper's single slice; split by patient.</a:t>
-            </a:r>
-          </a:p>
-          <a:p>
-            <a:pPr>
-              <a:spcBef>
-                <a:spcPts val="0"/>
-              </a:spcBef>
-              <a:spcAft>
-                <a:spcPts val="1100"/>
-              </a:spcAft>
-            </a:pPr>
-            <a:r>
-              <a:rPr sz="1350" b="1" i="0">
-                <a:solidFill>
-                  <a:srgbClr val="1A3A5C"/>
-                </a:solidFill>
-                <a:latin typeface="Calibri"/>
-              </a:rPr>
-              <a:t>▪  </a:t>
-            </a:r>
-            <a:r>
-              <a:rPr sz="1350" b="1" i="0">
-                <a:solidFill>
-                  <a:srgbClr val="1C2736"/>
-                </a:solidFill>
-                <a:latin typeface="Calibri"/>
-              </a:rPr>
-              <a:t>Training:</a:t>
-            </a:r>
-            <a:r>
-              <a:rPr sz="1350" b="0" i="0">
-                <a:solidFill>
-                  <a:srgbClr val="1C2736"/>
-                </a:solidFill>
-                <a:latin typeface="Calibri"/>
-              </a:rPr>
-              <a:t> LoRA (LLM) + full fine-tune vision; boxes written as </a:t>
-            </a:r>
-            <a:r>
-              <a:rPr sz="1350" b="1" i="0">
-                <a:solidFill>
-                  <a:srgbClr val="1C2736"/>
-                </a:solidFill>
-                <a:latin typeface="Calibri"/>
-              </a:rPr>
-              <a:t>coordinate text</a:t>
-            </a:r>
-            <a:r>
-              <a:rPr sz="1350" b="0" i="0">
-                <a:solidFill>
-                  <a:srgbClr val="1C2736"/>
-                </a:solidFill>
-                <a:latin typeface="Calibri"/>
-              </a:rPr>
-              <a:t> (0–1000).</a:t>
-            </a:r>
-          </a:p>
-          <a:p>
-            <a:pPr>
-              <a:spcBef>
-                <a:spcPts val="0"/>
-              </a:spcBef>
-              <a:spcAft>
-                <a:spcPts val="1100"/>
-              </a:spcAft>
-            </a:pPr>
-            <a:r>
-              <a:rPr sz="1350" b="1" i="0">
-                <a:solidFill>
-                  <a:srgbClr val="1A3A5C"/>
-                </a:solidFill>
-                <a:latin typeface="Calibri"/>
-              </a:rPr>
-              <a:t>▪  </a:t>
-            </a:r>
-            <a:r>
-              <a:rPr sz="1350" b="1" i="0">
-                <a:solidFill>
-                  <a:srgbClr val="1C2736"/>
-                </a:solidFill>
-                <a:latin typeface="Calibri"/>
-              </a:rPr>
-              <a:t>Evaluation (main contribution):</a:t>
-            </a:r>
-            <a:r>
-              <a:rPr sz="1350" b="0" i="0">
-                <a:solidFill>
-                  <a:srgbClr val="1C2736"/>
-                </a:solidFill>
-                <a:latin typeface="Calibri"/>
-              </a:rPr>
-              <a:t> per-patient + CI, </a:t>
-            </a:r>
-            <a:r>
-              <a:rPr sz="1350" b="1" i="0">
-                <a:solidFill>
-                  <a:srgbClr val="1C2736"/>
-                </a:solidFill>
-                <a:latin typeface="Calibri"/>
-              </a:rPr>
-              <a:t>detection/localization split</a:t>
-            </a:r>
-            <a:r>
-              <a:rPr sz="1350" b="0" i="0">
-                <a:solidFill>
-                  <a:srgbClr val="1C2736"/>
-                </a:solidFill>
-                <a:latin typeface="Calibri"/>
-              </a:rPr>
-              <a:t>, </a:t>
-            </a:r>
-            <a:r>
-              <a:rPr sz="1350" b="1" i="0">
-                <a:solidFill>
-                  <a:srgbClr val="1C2736"/>
-                </a:solidFill>
-                <a:latin typeface="Calibri"/>
-              </a:rPr>
-              <a:t>selective prediction</a:t>
-            </a:r>
-            <a:r>
-              <a:rPr sz="1350" b="0" i="0">
-                <a:solidFill>
-                  <a:srgbClr val="1C2736"/>
-                </a:solidFill>
-                <a:latin typeface="Calibri"/>
-              </a:rPr>
-              <a:t> (knows when unsure).</a:t>
-            </a:r>
-          </a:p>
-        </p:txBody>
-      </p:sp>
-      <p:pic>
-        <p:nvPicPr>
-          <p:cNvPr id="5" name="Picture 4" descr="iou_frozen_vs_unfrozen_en.png"/>
-          <p:cNvPicPr>
-            <a:picLocks noChangeAspect="1"/>
-          </p:cNvPicPr>
+              <a:t>Each choice fixes ONE MedRegA limitation</a:t>
+            </a:r>
+          </a:p>
+        </p:txBody>
+      </p:sp>
+      <p:graphicFrame>
+        <p:nvGraphicFramePr>
+          <p:cNvPr id="5" name="Table 4"/>
+          <p:cNvGraphicFramePr>
+            <a:graphicFrameLocks noGrp="1"/>
+          </p:cNvGraphicFramePr>
           <p:nvPr/>
-        </p:nvPicPr>
-        <p:blipFill>
-          <a:blip r:embed="rId2"/>
-          <a:stretch>
-            <a:fillRect/>
-          </a:stretch>
-        </p:blipFill>
-        <p:spPr>
-          <a:xfrm>
-            <a:off x="5669280" y="1161287"/>
-            <a:ext cx="3200400" cy="2556136"/>
-          </a:xfrm>
-          <a:prstGeom prst="rect">
-            <a:avLst/>
-          </a:prstGeom>
-        </p:spPr>
-      </p:pic>
-      <p:sp>
-        <p:nvSpPr>
-          <p:cNvPr id="6" name="TextBox 5"/>
-          <p:cNvSpPr txBox="1"/>
-          <p:nvPr/>
-        </p:nvSpPr>
-        <p:spPr>
-          <a:xfrm>
-            <a:off x="5669280" y="3744856"/>
-            <a:ext cx="3200400" cy="274320"/>
-          </a:xfrm>
-          <a:prstGeom prst="rect">
-            <a:avLst/>
-          </a:prstGeom>
-          <a:noFill/>
-        </p:spPr>
-        <p:txBody>
-          <a:bodyPr wrap="square" anchor="t" lIns="25400" rIns="25400" tIns="12700" bIns="12700">
-            <a:spAutoFit/>
-          </a:bodyPr>
-          <a:lstStyle/>
-          <a:p>
-            <a:pPr algn="ctr"/>
-            <a:r>
-              <a:rPr sz="800" b="0" i="1">
-                <a:solidFill>
-                  <a:srgbClr val="6B7F95"/>
-                </a:solidFill>
-                <a:latin typeface="Calibri"/>
-              </a:rPr>
-              <a:t>Unlocking vision = the key step</a:t>
-            </a:r>
-          </a:p>
-        </p:txBody>
-      </p:sp>
-      <p:sp>
-        <p:nvSpPr>
-          <p:cNvPr id="7" name="Rectangle 6"/>
+        </p:nvGraphicFramePr>
+        <p:xfrm>
+          <a:off x="365760" y="1417320"/>
+          <a:ext cx="8412480" cy="2834640"/>
+        </p:xfrm>
+        <a:graphic>
+          <a:graphicData uri="http://schemas.openxmlformats.org/drawingml/2006/table">
+            <a:tbl>
+              <a:tblPr>
+                <a:tableStyleId>{5C22544A-7EE6-4342-B048-85BDC9FD1C3A}</a:tableStyleId>
+              </a:tblPr>
+              <a:tblGrid>
+                <a:gridCol w="4023360"/>
+                <a:gridCol w="4389120"/>
+              </a:tblGrid>
+              <a:tr h="566928">
+                <a:tc>
+                  <a:txBody>
+                    <a:bodyPr/>
+                    <a:lstStyle/>
+                    <a:p>
+                      <a:r>
+                        <a:rPr sz="1200" b="1" i="0">
+                          <a:solidFill>
+                            <a:srgbClr val="FFFFFF"/>
+                          </a:solidFill>
+                          <a:latin typeface="Calibri"/>
+                        </a:rPr>
+                        <a:t>MedRegA limitation</a:t>
+                      </a:r>
+                    </a:p>
+                  </a:txBody>
+                  <a:tcPr anchor="ctr" marL="63500" marT="25400" marB="25400">
+                    <a:solidFill>
+                      <a:srgbClr val="1A3A5C"/>
+                    </a:solidFill>
+                  </a:tcPr>
+                </a:tc>
+                <a:tc>
+                  <a:txBody>
+                    <a:bodyPr/>
+                    <a:lstStyle/>
+                    <a:p>
+                      <a:r>
+                        <a:rPr sz="1200" b="1" i="0">
+                          <a:solidFill>
+                            <a:srgbClr val="FFFFFF"/>
+                          </a:solidFill>
+                          <a:latin typeface="Calibri"/>
+                        </a:rPr>
+                        <a:t>Our choice (why)</a:t>
+                      </a:r>
+                    </a:p>
+                  </a:txBody>
+                  <a:tcPr anchor="ctr" marL="63500" marT="25400" marB="25400">
+                    <a:solidFill>
+                      <a:srgbClr val="1A3A5C"/>
+                    </a:solidFill>
+                  </a:tcPr>
+                </a:tc>
+              </a:tr>
+              <a:tr h="566928">
+                <a:tc>
+                  <a:txBody>
+                    <a:bodyPr/>
+                    <a:lstStyle/>
+                    <a:p>
+                      <a:r>
+                        <a:rPr sz="1150" b="0" i="0">
+                          <a:solidFill>
+                            <a:srgbClr val="1C2736"/>
+                          </a:solidFill>
+                          <a:latin typeface="Calibri"/>
+                        </a:rPr>
+                        <a:t>Load on the </a:t>
+                      </a:r>
+                      <a:r>
+                        <a:rPr sz="1150" b="1" i="0">
+                          <a:solidFill>
+                            <a:srgbClr val="1C2736"/>
+                          </a:solidFill>
+                          <a:latin typeface="Calibri"/>
+                        </a:rPr>
+                        <a:t>40B LLM</a:t>
+                      </a:r>
+                      <a:r>
+                        <a:rPr sz="1150" b="0" i="0">
+                          <a:solidFill>
+                            <a:srgbClr val="1C2736"/>
+                          </a:solidFill>
+                          <a:latin typeface="Calibri"/>
+                        </a:rPr>
+                        <a:t>; “eyes” &amp; “bridge” frozen → localization not sharp</a:t>
+                      </a:r>
+                    </a:p>
+                  </a:txBody>
+                  <a:tcPr anchor="ctr" marL="63500" marT="12700" marB="12700">
+                    <a:solidFill>
+                      <a:srgbClr val="FFFFFF"/>
+                    </a:solidFill>
+                  </a:tcPr>
+                </a:tc>
+                <a:tc>
+                  <a:txBody>
+                    <a:bodyPr/>
+                    <a:lstStyle/>
+                    <a:p>
+                      <a:r>
+                        <a:rPr sz="1150" b="1" i="0">
+                          <a:solidFill>
+                            <a:srgbClr val="1C2736"/>
+                          </a:solidFill>
+                          <a:latin typeface="Calibri"/>
+                        </a:rPr>
+                        <a:t>Gemma 4 E4B (~8B)</a:t>
+                      </a:r>
+                      <a:r>
+                        <a:rPr sz="1150" b="0" i="0">
+                          <a:solidFill>
+                            <a:srgbClr val="1C2736"/>
+                          </a:solidFill>
+                          <a:latin typeface="Calibri"/>
+                        </a:rPr>
+                        <a:t> + </a:t>
+                      </a:r>
+                      <a:r>
+                        <a:rPr sz="1150" b="1" i="0">
+                          <a:solidFill>
+                            <a:srgbClr val="1C2736"/>
+                          </a:solidFill>
+                          <a:latin typeface="Calibri"/>
+                        </a:rPr>
+                        <a:t>unlock vision</a:t>
+                      </a:r>
+                      <a:r>
+                        <a:rPr sz="1150" b="0" i="0">
+                          <a:solidFill>
+                            <a:srgbClr val="1C2736"/>
+                          </a:solidFill>
+                          <a:latin typeface="Calibri"/>
+                        </a:rPr>
+                        <a:t> (pIoU 0.015→0.27)</a:t>
+                      </a:r>
+                    </a:p>
+                  </a:txBody>
+                  <a:tcPr anchor="ctr" marL="63500" marT="12700" marB="12700">
+                    <a:solidFill>
+                      <a:srgbClr val="FFFFFF"/>
+                    </a:solidFill>
+                  </a:tcPr>
+                </a:tc>
+              </a:tr>
+              <a:tr h="566928">
+                <a:tc>
+                  <a:txBody>
+                    <a:bodyPr/>
+                    <a:lstStyle/>
+                    <a:p>
+                      <a:r>
+                        <a:rPr sz="1150" b="0" i="0">
+                          <a:solidFill>
+                            <a:srgbClr val="1C2736"/>
+                          </a:solidFill>
+                          <a:latin typeface="Calibri"/>
+                        </a:rPr>
+                        <a:t>Only </a:t>
+                      </a:r>
+                      <a:r>
+                        <a:rPr sz="1150" b="1" i="0">
+                          <a:solidFill>
+                            <a:srgbClr val="1C2736"/>
+                          </a:solidFill>
+                          <a:latin typeface="Calibri"/>
+                        </a:rPr>
+                        <a:t>1 central slice</a:t>
+                      </a:r>
+                      <a:r>
+                        <a:rPr sz="1150" b="0" i="0">
+                          <a:solidFill>
+                            <a:srgbClr val="1C2736"/>
+                          </a:solidFill>
+                          <a:latin typeface="Calibri"/>
+                        </a:rPr>
+                        <a:t>, </a:t>
+                      </a:r>
+                      <a:r>
+                        <a:rPr sz="1150" b="1" i="0">
+                          <a:solidFill>
+                            <a:srgbClr val="1C2736"/>
+                          </a:solidFill>
+                          <a:latin typeface="Calibri"/>
+                        </a:rPr>
+                        <a:t>no negatives</a:t>
+                      </a:r>
+                      <a:r>
+                        <a:rPr sz="1150" b="0" i="0">
+                          <a:solidFill>
+                            <a:srgbClr val="1C2736"/>
+                          </a:solidFill>
+                          <a:latin typeface="Calibri"/>
+                        </a:rPr>
+                        <a:t>, coarse box</a:t>
+                      </a:r>
+                    </a:p>
+                  </a:txBody>
+                  <a:tcPr anchor="ctr" marL="63500" marT="12700" marB="12700">
+                    <a:solidFill>
+                      <a:srgbClr val="E8F0F8"/>
+                    </a:solidFill>
+                  </a:tcPr>
+                </a:tc>
+                <a:tc>
+                  <a:txBody>
+                    <a:bodyPr/>
+                    <a:lstStyle/>
+                    <a:p>
+                      <a:r>
+                        <a:rPr sz="1150" b="1" i="0">
+                          <a:solidFill>
+                            <a:srgbClr val="1C2736"/>
+                          </a:solidFill>
+                          <a:latin typeface="Calibri"/>
+                        </a:rPr>
+                        <a:t>Multi-slice + negatives + multi-box</a:t>
+                      </a:r>
+                      <a:r>
+                        <a:rPr sz="1150" b="0" i="0">
+                          <a:solidFill>
+                            <a:srgbClr val="1C2736"/>
+                          </a:solidFill>
+                          <a:latin typeface="Calibri"/>
+                        </a:rPr>
+                        <a:t> (per-lesion); split by patient</a:t>
+                      </a:r>
+                    </a:p>
+                  </a:txBody>
+                  <a:tcPr anchor="ctr" marL="63500" marT="12700" marB="12700">
+                    <a:solidFill>
+                      <a:srgbClr val="E8F0F8"/>
+                    </a:solidFill>
+                  </a:tcPr>
+                </a:tc>
+              </a:tr>
+              <a:tr h="566928">
+                <a:tc>
+                  <a:txBody>
+                    <a:bodyPr/>
+                    <a:lstStyle/>
+                    <a:p>
+                      <a:r>
+                        <a:rPr sz="1150" b="0" i="0">
+                          <a:solidFill>
+                            <a:srgbClr val="1C2736"/>
+                          </a:solidFill>
+                          <a:latin typeface="Calibri"/>
+                        </a:rPr>
+                        <a:t>Cost </a:t>
+                      </a:r>
+                      <a:r>
+                        <a:rPr sz="1150" b="1" i="0">
+                          <a:solidFill>
+                            <a:srgbClr val="1C2736"/>
+                          </a:solidFill>
+                          <a:latin typeface="Calibri"/>
+                        </a:rPr>
+                        <a:t>16×H800</a:t>
+                      </a:r>
+                      <a:r>
+                        <a:rPr sz="1150" b="0" i="0">
+                          <a:solidFill>
+                            <a:srgbClr val="1C2736"/>
+                          </a:solidFill>
+                          <a:latin typeface="Calibri"/>
+                        </a:rPr>
+                        <a:t> — out of reach for a student</a:t>
+                      </a:r>
+                    </a:p>
+                  </a:txBody>
+                  <a:tcPr anchor="ctr" marL="63500" marT="12700" marB="12700">
+                    <a:solidFill>
+                      <a:srgbClr val="FFFFFF"/>
+                    </a:solidFill>
+                  </a:tcPr>
+                </a:tc>
+                <a:tc>
+                  <a:txBody>
+                    <a:bodyPr/>
+                    <a:lstStyle/>
+                    <a:p>
+                      <a:r>
+                        <a:rPr sz="1150" b="1" i="0">
+                          <a:solidFill>
+                            <a:srgbClr val="1C2736"/>
+                          </a:solidFill>
+                          <a:latin typeface="Calibri"/>
+                        </a:rPr>
+                        <a:t>LoRA + full fine-tune vision</a:t>
+                      </a:r>
+                      <a:r>
+                        <a:rPr sz="1150" b="0" i="0">
+                          <a:solidFill>
+                            <a:srgbClr val="1C2736"/>
+                          </a:solidFill>
+                          <a:latin typeface="Calibri"/>
+                        </a:rPr>
+                        <a:t>, runs on </a:t>
+                      </a:r>
+                      <a:r>
+                        <a:rPr sz="1150" b="1" i="0">
+                          <a:solidFill>
+                            <a:srgbClr val="1C2736"/>
+                          </a:solidFill>
+                          <a:latin typeface="Calibri"/>
+                        </a:rPr>
+                        <a:t>1 GPU</a:t>
+                      </a:r>
+                    </a:p>
+                  </a:txBody>
+                  <a:tcPr anchor="ctr" marL="63500" marT="12700" marB="12700">
+                    <a:solidFill>
+                      <a:srgbClr val="FFFFFF"/>
+                    </a:solidFill>
+                  </a:tcPr>
+                </a:tc>
+              </a:tr>
+              <a:tr h="566928">
+                <a:tc>
+                  <a:txBody>
+                    <a:bodyPr/>
+                    <a:lstStyle/>
+                    <a:p>
+                      <a:r>
+                        <a:rPr sz="1150" b="1" i="0">
+                          <a:solidFill>
+                            <a:srgbClr val="1C2736"/>
+                          </a:solidFill>
+                          <a:latin typeface="Calibri"/>
+                        </a:rPr>
+                        <a:t>Per-image</a:t>
+                      </a:r>
+                      <a:r>
+                        <a:rPr sz="1150" b="0" i="0">
+                          <a:solidFill>
+                            <a:srgbClr val="1C2736"/>
+                          </a:solidFill>
+                          <a:latin typeface="Calibri"/>
+                        </a:rPr>
+                        <a:t> (pseudoreplication); no abstain / CI</a:t>
+                      </a:r>
+                    </a:p>
+                  </a:txBody>
+                  <a:tcPr anchor="ctr" marL="63500" marT="12700" marB="12700">
+                    <a:solidFill>
+                      <a:srgbClr val="E8F0F8"/>
+                    </a:solidFill>
+                  </a:tcPr>
+                </a:tc>
+                <a:tc>
+                  <a:txBody>
+                    <a:bodyPr/>
+                    <a:lstStyle/>
+                    <a:p>
+                      <a:r>
+                        <a:rPr sz="1150" b="1" i="0">
+                          <a:solidFill>
+                            <a:srgbClr val="1C2736"/>
+                          </a:solidFill>
+                          <a:latin typeface="Calibri"/>
+                        </a:rPr>
+                        <a:t>Per-patient + CI</a:t>
+                      </a:r>
+                      <a:r>
+                        <a:rPr sz="1150" b="0" i="0">
+                          <a:solidFill>
+                            <a:srgbClr val="1C2736"/>
+                          </a:solidFill>
+                          <a:latin typeface="Calibri"/>
+                        </a:rPr>
+                        <a:t>, detect/localize split, </a:t>
+                      </a:r>
+                      <a:r>
+                        <a:rPr sz="1150" b="1" i="0">
+                          <a:solidFill>
+                            <a:srgbClr val="1C2736"/>
+                          </a:solidFill>
+                          <a:latin typeface="Calibri"/>
+                        </a:rPr>
+                        <a:t>selective prediction</a:t>
+                      </a:r>
+                    </a:p>
+                  </a:txBody>
+                  <a:tcPr anchor="ctr" marL="63500" marT="12700" marB="12700">
+                    <a:solidFill>
+                      <a:srgbClr val="E8F0F8"/>
+                    </a:solidFill>
+                  </a:tcPr>
+                </a:tc>
+              </a:tr>
+            </a:tbl>
+          </a:graphicData>
+        </a:graphic>
+      </p:graphicFrame>
+      <p:sp>
+        <p:nvSpPr>
+          <p:cNvPr id="6" name="Rectangle 5"/>
           <p:cNvSpPr/>
           <p:nvPr/>
         </p:nvSpPr>
@@ -3838,7 +3925,7 @@
       </p:sp>
       <p:sp>
         <p:nvSpPr>
-          <p:cNvPr id="8" name="TextBox 7"/>
+          <p:cNvPr id="7" name="TextBox 6"/>
           <p:cNvSpPr txBox="1"/>
           <p:nvPr/>
         </p:nvSpPr>
@@ -3872,7 +3959,7 @@
       </p:sp>
       <p:sp>
         <p:nvSpPr>
-          <p:cNvPr id="9" name="TextBox 8"/>
+          <p:cNvPr id="8" name="TextBox 7"/>
           <p:cNvSpPr txBox="1"/>
           <p:nvPr/>
         </p:nvSpPr>

</xml_diff>

<commit_message>
cai_tien: deck 5p — mạch kết quả mới (công bố metric → vì sao fine-tune)
- S3 "Kết quả của nhóm": công bố metric đạt được (3 thẻ số lớn
  F1 0.89 / Sens 80% / pIoU 0.27 + phụ + không quên + caveat).
- S4 "Vì đâu? nhờ fine-tune": zero-shot 0.33 → fine-tune 0.89,
  chứng minh kết quả từ fine-tune chứ không chỉ đổi model.
- Bỏ slide "vs MedRegA" (không so công bằng được; MedRegA đã ở
  bảng slide 2). EN + VN.

Co-Authored-By: Claude Opus 4.8 <noreply@anthropic.com>
</commit_message>
<xml_diff>
--- a/seminar/cai_tien/slides_5min_EN.pptx
+++ b/seminar/cai_tien/slides_5min_EN.pptx
@@ -4019,7 +4019,7 @@
         <p:spPr>
           <a:xfrm>
             <a:off x="0" y="0"/>
-            <a:ext cx="9144000" cy="886968"/>
+            <a:ext cx="9144000" cy="1188720"/>
           </a:xfrm>
           <a:prstGeom prst="rect">
             <a:avLst/>
@@ -4062,7 +4062,7 @@
         </p:nvSpPr>
         <p:spPr>
           <a:xfrm>
-            <a:off x="320040" y="182880"/>
+            <a:off x="320040" y="109728"/>
             <a:ext cx="8503920" cy="548640"/>
           </a:xfrm>
           <a:prstGeom prst="rect">
@@ -4083,456 +4083,21 @@
                 </a:solidFill>
                 <a:latin typeface="Cambria"/>
               </a:rPr>
-              <a:t>Results vs baseline (zero-shot → fine-tuned)</a:t>
-            </a:r>
-          </a:p>
-        </p:txBody>
-      </p:sp>
-      <p:graphicFrame>
-        <p:nvGraphicFramePr>
-          <p:cNvPr id="4" name="Table 3"/>
-          <p:cNvGraphicFramePr>
-            <a:graphicFrameLocks noGrp="1"/>
-          </p:cNvGraphicFramePr>
-          <p:nvPr/>
-        </p:nvGraphicFramePr>
-        <p:xfrm>
-          <a:off x="365760" y="1069848"/>
-          <a:ext cx="5029200" cy="2194560"/>
-        </p:xfrm>
-        <a:graphic>
-          <a:graphicData uri="http://schemas.openxmlformats.org/drawingml/2006/table">
-            <a:tbl>
-              <a:tblPr>
-                <a:tableStyleId>{5C22544A-7EE6-4342-B048-85BDC9FD1C3A}</a:tableStyleId>
-              </a:tblPr>
-              <a:tblGrid>
-                <a:gridCol w="2651760"/>
-                <a:gridCol w="1188720"/>
-                <a:gridCol w="1188720"/>
-              </a:tblGrid>
-              <a:tr h="365760">
-                <a:tc>
-                  <a:txBody>
-                    <a:bodyPr/>
-                    <a:lstStyle/>
-                    <a:p>
-                      <a:r>
-                        <a:rPr sz="1100" b="1" i="0">
-                          <a:solidFill>
-                            <a:srgbClr val="FFFFFF"/>
-                          </a:solidFill>
-                          <a:latin typeface="Calibri"/>
-                        </a:rPr>
-                        <a:t>Metric</a:t>
-                      </a:r>
-                    </a:p>
-                  </a:txBody>
-                  <a:tcPr anchor="ctr" marL="63500" marT="25400" marB="25400">
-                    <a:solidFill>
-                      <a:srgbClr val="1A3A5C"/>
-                    </a:solidFill>
-                  </a:tcPr>
-                </a:tc>
-                <a:tc>
-                  <a:txBody>
-                    <a:bodyPr/>
-                    <a:lstStyle/>
-                    <a:p>
-                      <a:r>
-                        <a:rPr sz="1100" b="1" i="0">
-                          <a:solidFill>
-                            <a:srgbClr val="FFFFFF"/>
-                          </a:solidFill>
-                          <a:latin typeface="Calibri"/>
-                        </a:rPr>
-                        <a:t>Baseline</a:t>
-                      </a:r>
-                    </a:p>
-                  </a:txBody>
-                  <a:tcPr anchor="ctr" marL="63500" marT="25400" marB="25400">
-                    <a:solidFill>
-                      <a:srgbClr val="1A3A5C"/>
-                    </a:solidFill>
-                  </a:tcPr>
-                </a:tc>
-                <a:tc>
-                  <a:txBody>
-                    <a:bodyPr/>
-                    <a:lstStyle/>
-                    <a:p>
-                      <a:r>
-                        <a:rPr sz="1100" b="1" i="0">
-                          <a:solidFill>
-                            <a:srgbClr val="FFFFFF"/>
-                          </a:solidFill>
-                          <a:latin typeface="Calibri"/>
-                        </a:rPr>
-                        <a:t>Ours</a:t>
-                      </a:r>
-                    </a:p>
-                  </a:txBody>
-                  <a:tcPr anchor="ctr" marL="63500" marT="25400" marB="25400">
-                    <a:solidFill>
-                      <a:srgbClr val="1A3A5C"/>
-                    </a:solidFill>
-                  </a:tcPr>
-                </a:tc>
-              </a:tr>
-              <a:tr h="365760">
-                <a:tc>
-                  <a:txBody>
-                    <a:bodyPr/>
-                    <a:lstStyle/>
-                    <a:p>
-                      <a:r>
-                        <a:rPr sz="1100" b="1" i="0">
-                          <a:solidFill>
-                            <a:srgbClr val="1C2736"/>
-                          </a:solidFill>
-                          <a:latin typeface="Calibri"/>
-                        </a:rPr>
-                        <a:t>Detection F1 (patient)</a:t>
-                      </a:r>
-                    </a:p>
-                  </a:txBody>
-                  <a:tcPr anchor="ctr" marL="63500" marT="12700" marB="12700">
-                    <a:solidFill>
-                      <a:srgbClr val="FFFFFF"/>
-                    </a:solidFill>
-                  </a:tcPr>
-                </a:tc>
-                <a:tc>
-                  <a:txBody>
-                    <a:bodyPr/>
-                    <a:lstStyle/>
-                    <a:p>
-                      <a:r>
-                        <a:rPr sz="1100" b="0" i="0">
-                          <a:solidFill>
-                            <a:srgbClr val="1C2736"/>
-                          </a:solidFill>
-                          <a:latin typeface="Calibri"/>
-                        </a:rPr>
-                        <a:t>0.33</a:t>
-                      </a:r>
-                    </a:p>
-                  </a:txBody>
-                  <a:tcPr anchor="ctr" marL="63500" marT="12700" marB="12700">
-                    <a:solidFill>
-                      <a:srgbClr val="FFFFFF"/>
-                    </a:solidFill>
-                  </a:tcPr>
-                </a:tc>
-                <a:tc>
-                  <a:txBody>
-                    <a:bodyPr/>
-                    <a:lstStyle/>
-                    <a:p>
-                      <a:r>
-                        <a:rPr sz="1100" b="0" i="0">
-                          <a:solidFill>
-                            <a:srgbClr val="1C2736"/>
-                          </a:solidFill>
-                          <a:latin typeface="Calibri"/>
-                        </a:rPr>
-                        <a:t>0.89</a:t>
-                      </a:r>
-                    </a:p>
-                  </a:txBody>
-                  <a:tcPr anchor="ctr" marL="63500" marT="12700" marB="12700">
-                    <a:solidFill>
-                      <a:srgbClr val="FFFFFF"/>
-                    </a:solidFill>
-                  </a:tcPr>
-                </a:tc>
-              </a:tr>
-              <a:tr h="365760">
-                <a:tc>
-                  <a:txBody>
-                    <a:bodyPr/>
-                    <a:lstStyle/>
-                    <a:p>
-                      <a:r>
-                        <a:rPr sz="1100" b="1" i="0">
-                          <a:solidFill>
-                            <a:srgbClr val="1C2736"/>
-                          </a:solidFill>
-                          <a:latin typeface="Calibri"/>
-                        </a:rPr>
-                        <a:t>Sensitivity (catch tumor)</a:t>
-                      </a:r>
-                    </a:p>
-                  </a:txBody>
-                  <a:tcPr anchor="ctr" marL="63500" marT="12700" marB="12700">
-                    <a:solidFill>
-                      <a:srgbClr val="E8F0F8"/>
-                    </a:solidFill>
-                  </a:tcPr>
-                </a:tc>
-                <a:tc>
-                  <a:txBody>
-                    <a:bodyPr/>
-                    <a:lstStyle/>
-                    <a:p>
-                      <a:r>
-                        <a:rPr sz="1100" b="0" i="0">
-                          <a:solidFill>
-                            <a:srgbClr val="1C2736"/>
-                          </a:solidFill>
-                          <a:latin typeface="Calibri"/>
-                        </a:rPr>
-                        <a:t>20%</a:t>
-                      </a:r>
-                    </a:p>
-                  </a:txBody>
-                  <a:tcPr anchor="ctr" marL="63500" marT="12700" marB="12700">
-                    <a:solidFill>
-                      <a:srgbClr val="E8F0F8"/>
-                    </a:solidFill>
-                  </a:tcPr>
-                </a:tc>
-                <a:tc>
-                  <a:txBody>
-                    <a:bodyPr/>
-                    <a:lstStyle/>
-                    <a:p>
-                      <a:r>
-                        <a:rPr sz="1100" b="0" i="0">
-                          <a:solidFill>
-                            <a:srgbClr val="1C2736"/>
-                          </a:solidFill>
-                          <a:latin typeface="Calibri"/>
-                        </a:rPr>
-                        <a:t>80%</a:t>
-                      </a:r>
-                    </a:p>
-                  </a:txBody>
-                  <a:tcPr anchor="ctr" marL="63500" marT="12700" marB="12700">
-                    <a:solidFill>
-                      <a:srgbClr val="E8F0F8"/>
-                    </a:solidFill>
-                  </a:tcPr>
-                </a:tc>
-              </a:tr>
-              <a:tr h="365760">
-                <a:tc>
-                  <a:txBody>
-                    <a:bodyPr/>
-                    <a:lstStyle/>
-                    <a:p>
-                      <a:r>
-                        <a:rPr sz="1100" b="1" i="0">
-                          <a:solidFill>
-                            <a:srgbClr val="1C2736"/>
-                          </a:solidFill>
-                          <a:latin typeface="Calibri"/>
-                        </a:rPr>
-                        <a:t>Localization pIoU</a:t>
-                      </a:r>
-                    </a:p>
-                  </a:txBody>
-                  <a:tcPr anchor="ctr" marL="63500" marT="12700" marB="12700">
-                    <a:solidFill>
-                      <a:srgbClr val="FFFFFF"/>
-                    </a:solidFill>
-                  </a:tcPr>
-                </a:tc>
-                <a:tc>
-                  <a:txBody>
-                    <a:bodyPr/>
-                    <a:lstStyle/>
-                    <a:p>
-                      <a:r>
-                        <a:rPr sz="1100" b="0" i="0">
-                          <a:solidFill>
-                            <a:srgbClr val="1C2736"/>
-                          </a:solidFill>
-                          <a:latin typeface="Calibri"/>
-                        </a:rPr>
-                        <a:t>0.002</a:t>
-                      </a:r>
-                    </a:p>
-                  </a:txBody>
-                  <a:tcPr anchor="ctr" marL="63500" marT="12700" marB="12700">
-                    <a:solidFill>
-                      <a:srgbClr val="FFFFFF"/>
-                    </a:solidFill>
-                  </a:tcPr>
-                </a:tc>
-                <a:tc>
-                  <a:txBody>
-                    <a:bodyPr/>
-                    <a:lstStyle/>
-                    <a:p>
-                      <a:r>
-                        <a:rPr sz="1100" b="0" i="0">
-                          <a:solidFill>
-                            <a:srgbClr val="1C2736"/>
-                          </a:solidFill>
-                          <a:latin typeface="Calibri"/>
-                        </a:rPr>
-                        <a:t>0.27</a:t>
-                      </a:r>
-                    </a:p>
-                  </a:txBody>
-                  <a:tcPr anchor="ctr" marL="63500" marT="12700" marB="12700">
-                    <a:solidFill>
-                      <a:srgbClr val="FFFFFF"/>
-                    </a:solidFill>
-                  </a:tcPr>
-                </a:tc>
-              </a:tr>
-              <a:tr h="365760">
-                <a:tc>
-                  <a:txBody>
-                    <a:bodyPr/>
-                    <a:lstStyle/>
-                    <a:p>
-                      <a:r>
-                        <a:rPr sz="1100" b="1" i="0">
-                          <a:solidFill>
-                            <a:srgbClr val="1C2736"/>
-                          </a:solidFill>
-                          <a:latin typeface="Calibri"/>
-                        </a:rPr>
-                        <a:t>recall@IoU 0.25</a:t>
-                      </a:r>
-                    </a:p>
-                  </a:txBody>
-                  <a:tcPr anchor="ctr" marL="63500" marT="12700" marB="12700">
-                    <a:solidFill>
-                      <a:srgbClr val="E8F0F8"/>
-                    </a:solidFill>
-                  </a:tcPr>
-                </a:tc>
-                <a:tc>
-                  <a:txBody>
-                    <a:bodyPr/>
-                    <a:lstStyle/>
-                    <a:p>
-                      <a:r>
-                        <a:rPr sz="1100" b="0" i="0">
-                          <a:solidFill>
-                            <a:srgbClr val="1C2736"/>
-                          </a:solidFill>
-                          <a:latin typeface="Calibri"/>
-                        </a:rPr>
-                        <a:t>0%</a:t>
-                      </a:r>
-                    </a:p>
-                  </a:txBody>
-                  <a:tcPr anchor="ctr" marL="63500" marT="12700" marB="12700">
-                    <a:solidFill>
-                      <a:srgbClr val="E8F0F8"/>
-                    </a:solidFill>
-                  </a:tcPr>
-                </a:tc>
-                <a:tc>
-                  <a:txBody>
-                    <a:bodyPr/>
-                    <a:lstStyle/>
-                    <a:p>
-                      <a:r>
-                        <a:rPr sz="1100" b="0" i="0">
-                          <a:solidFill>
-                            <a:srgbClr val="1C2736"/>
-                          </a:solidFill>
-                          <a:latin typeface="Calibri"/>
-                        </a:rPr>
-                        <a:t>54%</a:t>
-                      </a:r>
-                    </a:p>
-                  </a:txBody>
-                  <a:tcPr anchor="ctr" marL="63500" marT="12700" marB="12700">
-                    <a:solidFill>
-                      <a:srgbClr val="E8F0F8"/>
-                    </a:solidFill>
-                  </a:tcPr>
-                </a:tc>
-              </a:tr>
-              <a:tr h="365760">
-                <a:tc>
-                  <a:txBody>
-                    <a:bodyPr/>
-                    <a:lstStyle/>
-                    <a:p>
-                      <a:r>
-                        <a:rPr sz="1100" b="1" i="0">
-                          <a:solidFill>
-                            <a:srgbClr val="1C2736"/>
-                          </a:solidFill>
-                          <a:latin typeface="Calibri"/>
-                        </a:rPr>
-                        <a:t>False-positive (neg. slice)</a:t>
-                      </a:r>
-                    </a:p>
-                  </a:txBody>
-                  <a:tcPr anchor="ctr" marL="63500" marT="12700" marB="12700">
-                    <a:solidFill>
-                      <a:srgbClr val="FFFFFF"/>
-                    </a:solidFill>
-                  </a:tcPr>
-                </a:tc>
-                <a:tc>
-                  <a:txBody>
-                    <a:bodyPr/>
-                    <a:lstStyle/>
-                    <a:p>
-                      <a:r>
-                        <a:rPr sz="1100" b="0" i="0">
-                          <a:solidFill>
-                            <a:srgbClr val="1C2736"/>
-                          </a:solidFill>
-                          <a:latin typeface="Calibri"/>
-                        </a:rPr>
-                        <a:t>2.2%</a:t>
-                      </a:r>
-                    </a:p>
-                  </a:txBody>
-                  <a:tcPr anchor="ctr" marL="63500" marT="12700" marB="12700">
-                    <a:solidFill>
-                      <a:srgbClr val="FFFFFF"/>
-                    </a:solidFill>
-                  </a:tcPr>
-                </a:tc>
-                <a:tc>
-                  <a:txBody>
-                    <a:bodyPr/>
-                    <a:lstStyle/>
-                    <a:p>
-                      <a:r>
-                        <a:rPr sz="1100" b="0" i="0">
-                          <a:solidFill>
-                            <a:srgbClr val="1C2736"/>
-                          </a:solidFill>
-                          <a:latin typeface="Calibri"/>
-                        </a:rPr>
-                        <a:t>1.5%</a:t>
-                      </a:r>
-                    </a:p>
-                  </a:txBody>
-                  <a:tcPr anchor="ctr" marL="63500" marT="12700" marB="12700">
-                    <a:solidFill>
-                      <a:srgbClr val="FFFFFF"/>
-                    </a:solidFill>
-                  </a:tcPr>
-                </a:tc>
-              </a:tr>
-            </a:tbl>
-          </a:graphicData>
-        </a:graphic>
-      </p:graphicFrame>
-      <p:sp>
-        <p:nvSpPr>
-          <p:cNvPr id="5" name="TextBox 4"/>
+              <a:t>Our results</a:t>
+            </a:r>
+          </a:p>
+        </p:txBody>
+      </p:sp>
+      <p:sp>
+        <p:nvSpPr>
+          <p:cNvPr id="4" name="TextBox 3"/>
           <p:cNvSpPr txBox="1"/>
           <p:nvPr/>
         </p:nvSpPr>
         <p:spPr>
           <a:xfrm>
-            <a:off x="365760" y="3172968"/>
-            <a:ext cx="5029200" cy="640080"/>
+            <a:off x="338328" y="694944"/>
+            <a:ext cx="8412480" cy="411480"/>
           </a:xfrm>
           <a:prstGeom prst="rect">
             <a:avLst/>
@@ -4545,60 +4110,34 @@
           </a:bodyPr>
           <a:lstStyle/>
           <a:p>
-            <a:pPr>
-              <a:spcBef>
-                <a:spcPts val="0"/>
-              </a:spcBef>
-              <a:spcAft>
-                <a:spcPts val="900"/>
-              </a:spcAft>
-            </a:pPr>
-            <a:r>
-              <a:rPr sz="1200" b="1" i="0">
-                <a:solidFill>
-                  <a:srgbClr val="1A3A5C"/>
-                </a:solidFill>
-                <a:latin typeface="Calibri"/>
-              </a:rPr>
-              <a:t>▪  </a:t>
-            </a:r>
-            <a:r>
-              <a:rPr sz="1200" b="1" i="0">
-                <a:solidFill>
-                  <a:srgbClr val="1C2736"/>
-                </a:solidFill>
-                <a:latin typeface="Calibri"/>
-              </a:rPr>
-              <a:t>No forgetting:</a:t>
-            </a:r>
-            <a:r>
-              <a:rPr sz="1200" b="0" i="0">
-                <a:solidFill>
-                  <a:srgbClr val="1C2736"/>
-                </a:solidFill>
-                <a:latin typeface="Calibri"/>
-              </a:rPr>
-              <a:t> still chats / JSON / poem / math (LoRA keeps base weights).</a:t>
-            </a:r>
-          </a:p>
-        </p:txBody>
-      </p:sp>
-      <p:sp>
-        <p:nvSpPr>
-          <p:cNvPr id="6" name="Rectangle 5"/>
+            <a:r>
+              <a:rPr sz="1150" b="0" i="1">
+                <a:solidFill>
+                  <a:srgbClr val="B8CFE0"/>
+                </a:solidFill>
+                <a:latin typeface="Calibri"/>
+              </a:rPr>
+              <a:t>What our model achieves — reported directly</a:t>
+            </a:r>
+          </a:p>
+        </p:txBody>
+      </p:sp>
+      <p:sp>
+        <p:nvSpPr>
+          <p:cNvPr id="5" name="Rectangle 4"/>
           <p:cNvSpPr/>
           <p:nvPr/>
         </p:nvSpPr>
         <p:spPr>
           <a:xfrm>
-            <a:off x="365760" y="3767328"/>
-            <a:ext cx="5029200" cy="640080"/>
+            <a:off x="365760" y="1435607"/>
+            <a:ext cx="2697480" cy="1234440"/>
           </a:xfrm>
           <a:prstGeom prst="rect">
             <a:avLst/>
           </a:prstGeom>
           <a:solidFill>
-            <a:srgbClr val="FBF1F1"/>
+            <a:srgbClr val="E8F0F8"/>
           </a:solidFill>
           <a:ln>
             <a:noFill/>
@@ -4629,14 +4168,14 @@
       </p:sp>
       <p:sp>
         <p:nvSpPr>
-          <p:cNvPr id="7" name="TextBox 6"/>
+          <p:cNvPr id="6" name="TextBox 5"/>
           <p:cNvSpPr txBox="1"/>
           <p:nvPr/>
         </p:nvSpPr>
         <p:spPr>
           <a:xfrm>
-            <a:off x="475488" y="3831336"/>
-            <a:ext cx="4809744" cy="512063"/>
+            <a:off x="365760" y="1563624"/>
+            <a:ext cx="2697480" cy="641908"/>
           </a:xfrm>
           <a:prstGeom prst="rect">
             <a:avLst/>
@@ -4644,73 +4183,34 @@
           <a:noFill/>
         </p:spPr>
         <p:txBody>
-          <a:bodyPr wrap="square" anchor="t" lIns="25400" rIns="25400" tIns="12700" bIns="12700">
+          <a:bodyPr wrap="square" anchor="b" lIns="25400" rIns="25400" tIns="12700" bIns="12700">
             <a:spAutoFit/>
           </a:bodyPr>
           <a:lstStyle/>
           <a:p>
-            <a:r>
-              <a:rPr sz="1050" b="1" i="0">
-                <a:solidFill>
-                  <a:srgbClr val="A04646"/>
-                </a:solidFill>
-                <a:latin typeface="Calibri"/>
-              </a:rPr>
-              <a:t>⚠ Note</a:t>
-            </a:r>
-          </a:p>
-          <a:p>
-            <a:pPr>
-              <a:spcBef>
-                <a:spcPts val="100"/>
-              </a:spcBef>
-            </a:pPr>
-            <a:r>
-              <a:rPr sz="1000" b="0" i="0">
-                <a:solidFill>
-                  <a:srgbClr val="1C2736"/>
-                </a:solidFill>
-                <a:latin typeface="Calibri"/>
-              </a:rPr>
-              <a:t>small n (~25 pos patients, 2 neg) → wide CI; this is a PoC, no clinical claim.</a:t>
-            </a:r>
-          </a:p>
-        </p:txBody>
-      </p:sp>
-      <p:pic>
-        <p:nvPicPr>
-          <p:cNvPr id="8" name="Picture 7" descr="detect_before_after_en.png"/>
-          <p:cNvPicPr>
-            <a:picLocks noChangeAspect="1"/>
-          </p:cNvPicPr>
-          <p:nvPr/>
-        </p:nvPicPr>
-        <p:blipFill>
-          <a:blip r:embed="rId2"/>
-          <a:stretch>
-            <a:fillRect/>
-          </a:stretch>
-        </p:blipFill>
-        <p:spPr>
-          <a:xfrm>
-            <a:off x="5577840" y="1252728"/>
-            <a:ext cx="3383280" cy="1953725"/>
-          </a:xfrm>
-          <a:prstGeom prst="rect">
-            <a:avLst/>
-          </a:prstGeom>
-        </p:spPr>
-      </p:pic>
-      <p:sp>
-        <p:nvSpPr>
-          <p:cNvPr id="9" name="TextBox 8"/>
+            <a:pPr algn="ctr"/>
+            <a:r>
+              <a:rPr sz="3200" b="1" i="0">
+                <a:solidFill>
+                  <a:srgbClr val="1A3A5C"/>
+                </a:solidFill>
+                <a:latin typeface="Cambria"/>
+              </a:rPr>
+              <a:t>0.89</a:t>
+            </a:r>
+          </a:p>
+        </p:txBody>
+      </p:sp>
+      <p:sp>
+        <p:nvSpPr>
+          <p:cNvPr id="7" name="TextBox 6"/>
           <p:cNvSpPr txBox="1"/>
           <p:nvPr/>
         </p:nvSpPr>
         <p:spPr>
           <a:xfrm>
-            <a:off x="5577840" y="3233885"/>
-            <a:ext cx="3383280" cy="274320"/>
+            <a:off x="457200" y="2151583"/>
+            <a:ext cx="2514600" cy="493776"/>
           </a:xfrm>
           <a:prstGeom prst="rect">
             <a:avLst/>
@@ -4725,33 +4225,33 @@
           <a:p>
             <a:pPr algn="ctr"/>
             <a:r>
-              <a:rPr sz="800" b="0" i="1">
-                <a:solidFill>
-                  <a:srgbClr val="6B7F95"/>
-                </a:solidFill>
-                <a:latin typeface="Calibri"/>
-              </a:rPr>
-              <a:t>Before → after fine-tune</a:t>
-            </a:r>
-          </a:p>
-        </p:txBody>
-      </p:sp>
-      <p:sp>
-        <p:nvSpPr>
-          <p:cNvPr id="10" name="Rectangle 9"/>
+              <a:rPr sz="1100" b="0" i="0">
+                <a:solidFill>
+                  <a:srgbClr val="1C2736"/>
+                </a:solidFill>
+                <a:latin typeface="Calibri"/>
+              </a:rPr>
+              <a:t>Detection F1 (patient)</a:t>
+            </a:r>
+          </a:p>
+        </p:txBody>
+      </p:sp>
+      <p:sp>
+        <p:nvSpPr>
+          <p:cNvPr id="8" name="Rectangle 7"/>
           <p:cNvSpPr/>
           <p:nvPr/>
         </p:nvSpPr>
         <p:spPr>
           <a:xfrm>
-            <a:off x="0" y="4882896"/>
-            <a:ext cx="9144000" cy="265176"/>
+            <a:off x="3227832" y="1435607"/>
+            <a:ext cx="2697480" cy="1234440"/>
           </a:xfrm>
           <a:prstGeom prst="rect">
             <a:avLst/>
           </a:prstGeom>
           <a:solidFill>
-            <a:srgbClr val="EEF4FB"/>
+            <a:srgbClr val="E8F0F8"/>
           </a:solidFill>
           <a:ln>
             <a:noFill/>
@@ -4782,14 +4282,14 @@
       </p:sp>
       <p:sp>
         <p:nvSpPr>
-          <p:cNvPr id="11" name="TextBox 10"/>
+          <p:cNvPr id="9" name="TextBox 8"/>
           <p:cNvSpPr txBox="1"/>
           <p:nvPr/>
         </p:nvSpPr>
         <p:spPr>
           <a:xfrm>
-            <a:off x="320040" y="4937760"/>
-            <a:ext cx="6400800" cy="164592"/>
+            <a:off x="3227832" y="1563624"/>
+            <a:ext cx="2697480" cy="641908"/>
           </a:xfrm>
           <a:prstGeom prst="rect">
             <a:avLst/>
@@ -4797,11 +4297,494 @@
           <a:noFill/>
         </p:spPr>
         <p:txBody>
+          <a:bodyPr wrap="square" anchor="b" lIns="25400" rIns="25400" tIns="12700" bIns="12700">
+            <a:spAutoFit/>
+          </a:bodyPr>
+          <a:lstStyle/>
+          <a:p>
+            <a:pPr algn="ctr"/>
+            <a:r>
+              <a:rPr sz="3200" b="1" i="0">
+                <a:solidFill>
+                  <a:srgbClr val="1A3A5C"/>
+                </a:solidFill>
+                <a:latin typeface="Cambria"/>
+              </a:rPr>
+              <a:t>80%</a:t>
+            </a:r>
+          </a:p>
+        </p:txBody>
+      </p:sp>
+      <p:sp>
+        <p:nvSpPr>
+          <p:cNvPr id="10" name="TextBox 9"/>
+          <p:cNvSpPr txBox="1"/>
+          <p:nvPr/>
+        </p:nvSpPr>
+        <p:spPr>
+          <a:xfrm>
+            <a:off x="3319272" y="2151583"/>
+            <a:ext cx="2514600" cy="493776"/>
+          </a:xfrm>
+          <a:prstGeom prst="rect">
+            <a:avLst/>
+          </a:prstGeom>
+          <a:noFill/>
+        </p:spPr>
+        <p:txBody>
           <a:bodyPr wrap="square" anchor="t" lIns="25400" rIns="25400" tIns="12700" bIns="12700">
             <a:spAutoFit/>
           </a:bodyPr>
           <a:lstStyle/>
           <a:p>
+            <a:pPr algn="ctr"/>
+            <a:r>
+              <a:rPr sz="1100" b="0" i="0">
+                <a:solidFill>
+                  <a:srgbClr val="1C2736"/>
+                </a:solidFill>
+                <a:latin typeface="Calibri"/>
+              </a:rPr>
+              <a:t>Sensitivity — catch tumors</a:t>
+            </a:r>
+          </a:p>
+        </p:txBody>
+      </p:sp>
+      <p:sp>
+        <p:nvSpPr>
+          <p:cNvPr id="11" name="Rectangle 10"/>
+          <p:cNvSpPr/>
+          <p:nvPr/>
+        </p:nvSpPr>
+        <p:spPr>
+          <a:xfrm>
+            <a:off x="6089904" y="1435607"/>
+            <a:ext cx="2697480" cy="1234440"/>
+          </a:xfrm>
+          <a:prstGeom prst="rect">
+            <a:avLst/>
+          </a:prstGeom>
+          <a:solidFill>
+            <a:srgbClr val="E8F0F8"/>
+          </a:solidFill>
+          <a:ln>
+            <a:noFill/>
+          </a:ln>
+          <a:effectLst/>
+        </p:spPr>
+        <p:style>
+          <a:lnRef idx="1">
+            <a:schemeClr val="accent1"/>
+          </a:lnRef>
+          <a:fillRef idx="3">
+            <a:schemeClr val="accent1"/>
+          </a:fillRef>
+          <a:effectRef idx="2">
+            <a:schemeClr val="accent1"/>
+          </a:effectRef>
+          <a:fontRef idx="minor">
+            <a:schemeClr val="lt1"/>
+          </a:fontRef>
+        </p:style>
+        <p:txBody>
+          <a:bodyPr rtlCol="0" anchor="ctr"/>
+          <a:lstStyle/>
+          <a:p>
+            <a:pPr algn="ctr"/>
+          </a:p>
+        </p:txBody>
+      </p:sp>
+      <p:sp>
+        <p:nvSpPr>
+          <p:cNvPr id="12" name="TextBox 11"/>
+          <p:cNvSpPr txBox="1"/>
+          <p:nvPr/>
+        </p:nvSpPr>
+        <p:spPr>
+          <a:xfrm>
+            <a:off x="6089904" y="1563624"/>
+            <a:ext cx="2697480" cy="641908"/>
+          </a:xfrm>
+          <a:prstGeom prst="rect">
+            <a:avLst/>
+          </a:prstGeom>
+          <a:noFill/>
+        </p:spPr>
+        <p:txBody>
+          <a:bodyPr wrap="square" anchor="b" lIns="25400" rIns="25400" tIns="12700" bIns="12700">
+            <a:spAutoFit/>
+          </a:bodyPr>
+          <a:lstStyle/>
+          <a:p>
+            <a:pPr algn="ctr"/>
+            <a:r>
+              <a:rPr sz="3200" b="1" i="0">
+                <a:solidFill>
+                  <a:srgbClr val="1A3A5C"/>
+                </a:solidFill>
+                <a:latin typeface="Cambria"/>
+              </a:rPr>
+              <a:t>0.27</a:t>
+            </a:r>
+          </a:p>
+        </p:txBody>
+      </p:sp>
+      <p:sp>
+        <p:nvSpPr>
+          <p:cNvPr id="13" name="TextBox 12"/>
+          <p:cNvSpPr txBox="1"/>
+          <p:nvPr/>
+        </p:nvSpPr>
+        <p:spPr>
+          <a:xfrm>
+            <a:off x="6181344" y="2151583"/>
+            <a:ext cx="2514600" cy="493776"/>
+          </a:xfrm>
+          <a:prstGeom prst="rect">
+            <a:avLst/>
+          </a:prstGeom>
+          <a:noFill/>
+        </p:spPr>
+        <p:txBody>
+          <a:bodyPr wrap="square" anchor="t" lIns="25400" rIns="25400" tIns="12700" bIns="12700">
+            <a:spAutoFit/>
+          </a:bodyPr>
+          <a:lstStyle/>
+          <a:p>
+            <a:pPr algn="ctr"/>
+            <a:r>
+              <a:rPr sz="1100" b="0" i="0">
+                <a:solidFill>
+                  <a:srgbClr val="1C2736"/>
+                </a:solidFill>
+                <a:latin typeface="Calibri"/>
+              </a:rPr>
+              <a:t>Localization pIoU</a:t>
+            </a:r>
+          </a:p>
+        </p:txBody>
+      </p:sp>
+      <p:sp>
+        <p:nvSpPr>
+          <p:cNvPr id="14" name="TextBox 13"/>
+          <p:cNvSpPr txBox="1"/>
+          <p:nvPr/>
+        </p:nvSpPr>
+        <p:spPr>
+          <a:xfrm>
+            <a:off x="365760" y="2825496"/>
+            <a:ext cx="8412480" cy="1371600"/>
+          </a:xfrm>
+          <a:prstGeom prst="rect">
+            <a:avLst/>
+          </a:prstGeom>
+          <a:noFill/>
+        </p:spPr>
+        <p:txBody>
+          <a:bodyPr wrap="square" anchor="t" lIns="25400" rIns="25400" tIns="12700" bIns="12700">
+            <a:spAutoFit/>
+          </a:bodyPr>
+          <a:lstStyle/>
+          <a:p>
+            <a:pPr>
+              <a:spcBef>
+                <a:spcPts val="0"/>
+              </a:spcBef>
+              <a:spcAft>
+                <a:spcPts val="800"/>
+              </a:spcAft>
+            </a:pPr>
+            <a:r>
+              <a:rPr sz="1250" b="1" i="0">
+                <a:solidFill>
+                  <a:srgbClr val="1A3A5C"/>
+                </a:solidFill>
+                <a:latin typeface="Calibri"/>
+              </a:rPr>
+              <a:t>▪  </a:t>
+            </a:r>
+            <a:r>
+              <a:rPr sz="1250" b="1" i="0">
+                <a:solidFill>
+                  <a:srgbClr val="1C2736"/>
+                </a:solidFill>
+                <a:latin typeface="Calibri"/>
+              </a:rPr>
+              <a:t>recall@IoU.25 = 54%</a:t>
+            </a:r>
+            <a:r>
+              <a:rPr sz="1250" b="0" i="0">
+                <a:solidFill>
+                  <a:srgbClr val="1C2736"/>
+                </a:solidFill>
+                <a:latin typeface="Calibri"/>
+              </a:rPr>
+              <a:t> · </a:t>
+            </a:r>
+            <a:r>
+              <a:rPr sz="1250" b="1" i="0">
+                <a:solidFill>
+                  <a:srgbClr val="1C2736"/>
+                </a:solidFill>
+                <a:latin typeface="Calibri"/>
+              </a:rPr>
+              <a:t>False-positive = 1.5%</a:t>
+            </a:r>
+            <a:r>
+              <a:rPr sz="1250" b="0" i="0">
+                <a:solidFill>
+                  <a:srgbClr val="1C2736"/>
+                </a:solidFill>
+                <a:latin typeface="Calibri"/>
+              </a:rPr>
+              <a:t> (rarely invents boxes) · pIoU CI95 [0.19, 0.36].</a:t>
+            </a:r>
+          </a:p>
+          <a:p>
+            <a:pPr>
+              <a:spcBef>
+                <a:spcPts val="0"/>
+              </a:spcBef>
+              <a:spcAft>
+                <a:spcPts val="800"/>
+              </a:spcAft>
+            </a:pPr>
+            <a:r>
+              <a:rPr sz="1250" b="1" i="0">
+                <a:solidFill>
+                  <a:srgbClr val="1A3A5C"/>
+                </a:solidFill>
+                <a:latin typeface="Calibri"/>
+              </a:rPr>
+              <a:t>▪  </a:t>
+            </a:r>
+            <a:r>
+              <a:rPr sz="1250" b="1" i="0">
+                <a:solidFill>
+                  <a:srgbClr val="1C2736"/>
+                </a:solidFill>
+                <a:latin typeface="Calibri"/>
+              </a:rPr>
+              <a:t>No forgetting:</a:t>
+            </a:r>
+            <a:r>
+              <a:rPr sz="1250" b="0" i="0">
+                <a:solidFill>
+                  <a:srgbClr val="1C2736"/>
+                </a:solidFill>
+                <a:latin typeface="Calibri"/>
+              </a:rPr>
+              <a:t> still chats / JSON / poem / math (LoRA keeps base weights).</a:t>
+            </a:r>
+          </a:p>
+          <a:p>
+            <a:pPr>
+              <a:spcBef>
+                <a:spcPts val="0"/>
+              </a:spcBef>
+              <a:spcAft>
+                <a:spcPts val="800"/>
+              </a:spcAft>
+            </a:pPr>
+            <a:r>
+              <a:rPr sz="1250" b="1" i="0">
+                <a:solidFill>
+                  <a:srgbClr val="1A3A5C"/>
+                </a:solidFill>
+                <a:latin typeface="Calibri"/>
+              </a:rPr>
+              <a:t>▪  </a:t>
+            </a:r>
+            <a:r>
+              <a:rPr sz="1250" b="0" i="0">
+                <a:solidFill>
+                  <a:srgbClr val="1C2736"/>
+                </a:solidFill>
+                <a:latin typeface="Calibri"/>
+              </a:rPr>
+              <a:t>Localization ~0.27 ≈ </a:t>
+            </a:r>
+            <a:r>
+              <a:rPr sz="1250" b="1" i="0">
+                <a:solidFill>
+                  <a:srgbClr val="1C2736"/>
+                </a:solidFill>
+                <a:latin typeface="Calibri"/>
+              </a:rPr>
+              <a:t>same ballpark as MedRegA (~0.23)</a:t>
+            </a:r>
+            <a:r>
+              <a:rPr sz="1250" b="0" i="0">
+                <a:solidFill>
+                  <a:srgbClr val="1C2736"/>
+                </a:solidFill>
+                <a:latin typeface="Calibri"/>
+              </a:rPr>
+              <a:t> despite 5× smaller — different dataset, reference only.</a:t>
+            </a:r>
+          </a:p>
+        </p:txBody>
+      </p:sp>
+      <p:sp>
+        <p:nvSpPr>
+          <p:cNvPr id="15" name="Rectangle 14"/>
+          <p:cNvSpPr/>
+          <p:nvPr/>
+        </p:nvSpPr>
+        <p:spPr>
+          <a:xfrm>
+            <a:off x="365760" y="4178808"/>
+            <a:ext cx="8412480" cy="548640"/>
+          </a:xfrm>
+          <a:prstGeom prst="rect">
+            <a:avLst/>
+          </a:prstGeom>
+          <a:solidFill>
+            <a:srgbClr val="FBF1F1"/>
+          </a:solidFill>
+          <a:ln>
+            <a:noFill/>
+          </a:ln>
+          <a:effectLst/>
+        </p:spPr>
+        <p:style>
+          <a:lnRef idx="1">
+            <a:schemeClr val="accent1"/>
+          </a:lnRef>
+          <a:fillRef idx="3">
+            <a:schemeClr val="accent1"/>
+          </a:fillRef>
+          <a:effectRef idx="2">
+            <a:schemeClr val="accent1"/>
+          </a:effectRef>
+          <a:fontRef idx="minor">
+            <a:schemeClr val="lt1"/>
+          </a:fontRef>
+        </p:style>
+        <p:txBody>
+          <a:bodyPr rtlCol="0" anchor="ctr"/>
+          <a:lstStyle/>
+          <a:p>
+            <a:pPr algn="ctr"/>
+          </a:p>
+        </p:txBody>
+      </p:sp>
+      <p:sp>
+        <p:nvSpPr>
+          <p:cNvPr id="16" name="TextBox 15"/>
+          <p:cNvSpPr txBox="1"/>
+          <p:nvPr/>
+        </p:nvSpPr>
+        <p:spPr>
+          <a:xfrm>
+            <a:off x="475488" y="4242816"/>
+            <a:ext cx="8193023" cy="420623"/>
+          </a:xfrm>
+          <a:prstGeom prst="rect">
+            <a:avLst/>
+          </a:prstGeom>
+          <a:noFill/>
+        </p:spPr>
+        <p:txBody>
+          <a:bodyPr wrap="square" anchor="t" lIns="25400" rIns="25400" tIns="12700" bIns="12700">
+            <a:spAutoFit/>
+          </a:bodyPr>
+          <a:lstStyle/>
+          <a:p>
+            <a:r>
+              <a:rPr sz="1050" b="1" i="0">
+                <a:solidFill>
+                  <a:srgbClr val="A04646"/>
+                </a:solidFill>
+                <a:latin typeface="Calibri"/>
+              </a:rPr>
+              <a:t>⚠ Note</a:t>
+            </a:r>
+          </a:p>
+          <a:p>
+            <a:pPr>
+              <a:spcBef>
+                <a:spcPts val="100"/>
+              </a:spcBef>
+            </a:pPr>
+            <a:r>
+              <a:rPr sz="1000" b="0" i="0">
+                <a:solidFill>
+                  <a:srgbClr val="1C2736"/>
+                </a:solidFill>
+                <a:latin typeface="Calibri"/>
+              </a:rPr>
+              <a:t>small n (~25 pos patients / 2 neg) → wide CI; a PoC, no clinical claim.</a:t>
+            </a:r>
+          </a:p>
+        </p:txBody>
+      </p:sp>
+      <p:sp>
+        <p:nvSpPr>
+          <p:cNvPr id="17" name="Rectangle 16"/>
+          <p:cNvSpPr/>
+          <p:nvPr/>
+        </p:nvSpPr>
+        <p:spPr>
+          <a:xfrm>
+            <a:off x="0" y="4882896"/>
+            <a:ext cx="9144000" cy="265176"/>
+          </a:xfrm>
+          <a:prstGeom prst="rect">
+            <a:avLst/>
+          </a:prstGeom>
+          <a:solidFill>
+            <a:srgbClr val="EEF4FB"/>
+          </a:solidFill>
+          <a:ln>
+            <a:noFill/>
+          </a:ln>
+          <a:effectLst/>
+        </p:spPr>
+        <p:style>
+          <a:lnRef idx="1">
+            <a:schemeClr val="accent1"/>
+          </a:lnRef>
+          <a:fillRef idx="3">
+            <a:schemeClr val="accent1"/>
+          </a:fillRef>
+          <a:effectRef idx="2">
+            <a:schemeClr val="accent1"/>
+          </a:effectRef>
+          <a:fontRef idx="minor">
+            <a:schemeClr val="lt1"/>
+          </a:fontRef>
+        </p:style>
+        <p:txBody>
+          <a:bodyPr rtlCol="0" anchor="ctr"/>
+          <a:lstStyle/>
+          <a:p>
+            <a:pPr algn="ctr"/>
+          </a:p>
+        </p:txBody>
+      </p:sp>
+      <p:sp>
+        <p:nvSpPr>
+          <p:cNvPr id="18" name="TextBox 17"/>
+          <p:cNvSpPr txBox="1"/>
+          <p:nvPr/>
+        </p:nvSpPr>
+        <p:spPr>
+          <a:xfrm>
+            <a:off x="320040" y="4937760"/>
+            <a:ext cx="6400800" cy="164592"/>
+          </a:xfrm>
+          <a:prstGeom prst="rect">
+            <a:avLst/>
+          </a:prstGeom>
+          <a:noFill/>
+        </p:spPr>
+        <p:txBody>
+          <a:bodyPr wrap="square" anchor="t" lIns="25400" rIns="25400" tIns="12700" bIns="12700">
+            <a:spAutoFit/>
+          </a:bodyPr>
+          <a:lstStyle/>
+          <a:p>
             <a:r>
               <a:rPr sz="850" b="0" i="0">
                 <a:solidFill>
@@ -4816,7 +4799,7 @@
       </p:sp>
       <p:sp>
         <p:nvSpPr>
-          <p:cNvPr id="12" name="TextBox 11"/>
+          <p:cNvPr id="19" name="TextBox 18"/>
           <p:cNvSpPr txBox="1"/>
           <p:nvPr/>
         </p:nvSpPr>
@@ -4876,7 +4859,7 @@
         <p:spPr>
           <a:xfrm>
             <a:off x="0" y="0"/>
-            <a:ext cx="9144000" cy="886968"/>
+            <a:ext cx="9144000" cy="1188720"/>
           </a:xfrm>
           <a:prstGeom prst="rect">
             <a:avLst/>
@@ -4919,7 +4902,7 @@
         </p:nvSpPr>
         <p:spPr>
           <a:xfrm>
-            <a:off x="320040" y="182880"/>
+            <a:off x="320040" y="109728"/>
             <a:ext cx="8503920" cy="548640"/>
           </a:xfrm>
           <a:prstGeom prst="rect">
@@ -4940,524 +4923,338 @@
                 </a:solidFill>
                 <a:latin typeface="Cambria"/>
               </a:rPr>
-              <a:t>Results vs MedRegA</a:t>
-            </a:r>
-          </a:p>
-        </p:txBody>
-      </p:sp>
-      <p:graphicFrame>
-        <p:nvGraphicFramePr>
-          <p:cNvPr id="4" name="Table 3"/>
-          <p:cNvGraphicFramePr>
-            <a:graphicFrameLocks noGrp="1"/>
-          </p:cNvGraphicFramePr>
+              <a:t>Where do the gains come from? — fine-tuning</a:t>
+            </a:r>
+          </a:p>
+        </p:txBody>
+      </p:sp>
+      <p:sp>
+        <p:nvSpPr>
+          <p:cNvPr id="4" name="TextBox 3"/>
+          <p:cNvSpPr txBox="1"/>
           <p:nvPr/>
-        </p:nvGraphicFramePr>
-        <p:xfrm>
-          <a:off x="365760" y="1069848"/>
-          <a:ext cx="5486400" cy="2304288"/>
-        </p:xfrm>
-        <a:graphic>
-          <a:graphicData uri="http://schemas.openxmlformats.org/drawingml/2006/table">
-            <a:tbl>
-              <a:tblPr>
-                <a:tableStyleId>{5C22544A-7EE6-4342-B048-85BDC9FD1C3A}</a:tableStyleId>
-              </a:tblPr>
-              <a:tblGrid>
-                <a:gridCol w="1828800"/>
-                <a:gridCol w="1828800"/>
-                <a:gridCol w="1828800"/>
-              </a:tblGrid>
-              <a:tr h="329184">
-                <a:tc>
-                  <a:txBody>
-                    <a:bodyPr/>
-                    <a:lstStyle/>
-                    <a:p>
-                      <a:r>
-                        <a:rPr sz="1050" b="1" i="0">
-                          <a:solidFill>
-                            <a:srgbClr val="FFFFFF"/>
-                          </a:solidFill>
-                          <a:latin typeface="Calibri"/>
-                        </a:rPr>
-                        <a:t>Aspect</a:t>
-                      </a:r>
-                    </a:p>
-                  </a:txBody>
-                  <a:tcPr anchor="ctr" marL="63500" marT="25400" marB="25400">
-                    <a:solidFill>
-                      <a:srgbClr val="1A3A5C"/>
-                    </a:solidFill>
-                  </a:tcPr>
-                </a:tc>
-                <a:tc>
-                  <a:txBody>
-                    <a:bodyPr/>
-                    <a:lstStyle/>
-                    <a:p>
-                      <a:r>
-                        <a:rPr sz="1050" b="1" i="0">
-                          <a:solidFill>
-                            <a:srgbClr val="FFFFFF"/>
-                          </a:solidFill>
-                          <a:latin typeface="Calibri"/>
-                        </a:rPr>
-                        <a:t>MedRegA</a:t>
-                      </a:r>
-                    </a:p>
-                  </a:txBody>
-                  <a:tcPr anchor="ctr" marL="63500" marT="25400" marB="25400">
-                    <a:solidFill>
-                      <a:srgbClr val="1A3A5C"/>
-                    </a:solidFill>
-                  </a:tcPr>
-                </a:tc>
-                <a:tc>
-                  <a:txBody>
-                    <a:bodyPr/>
-                    <a:lstStyle/>
-                    <a:p>
-                      <a:r>
-                        <a:rPr sz="1050" b="1" i="0">
-                          <a:solidFill>
-                            <a:srgbClr val="FFFFFF"/>
-                          </a:solidFill>
-                          <a:latin typeface="Calibri"/>
-                        </a:rPr>
-                        <a:t>Ours</a:t>
-                      </a:r>
-                    </a:p>
-                  </a:txBody>
-                  <a:tcPr anchor="ctr" marL="63500" marT="25400" marB="25400">
-                    <a:solidFill>
-                      <a:srgbClr val="1A3A5C"/>
-                    </a:solidFill>
-                  </a:tcPr>
-                </a:tc>
-              </a:tr>
-              <a:tr h="329184">
-                <a:tc>
-                  <a:txBody>
-                    <a:bodyPr/>
-                    <a:lstStyle/>
-                    <a:p>
-                      <a:r>
-                        <a:rPr sz="1000" b="1" i="0">
-                          <a:solidFill>
-                            <a:srgbClr val="1C2736"/>
-                          </a:solidFill>
-                          <a:latin typeface="Calibri"/>
-                        </a:rPr>
-                        <a:t>Scale</a:t>
-                      </a:r>
-                    </a:p>
-                  </a:txBody>
-                  <a:tcPr anchor="ctr" marL="63500" marT="12700" marB="12700">
-                    <a:solidFill>
-                      <a:srgbClr val="FFFFFF"/>
-                    </a:solidFill>
-                  </a:tcPr>
-                </a:tc>
-                <a:tc>
-                  <a:txBody>
-                    <a:bodyPr/>
-                    <a:lstStyle/>
-                    <a:p>
-                      <a:r>
-                        <a:rPr sz="1000" b="0" i="0">
-                          <a:solidFill>
-                            <a:srgbClr val="1C2736"/>
-                          </a:solidFill>
-                          <a:latin typeface="Calibri"/>
-                        </a:rPr>
-                        <a:t>~40B, 16×H800</a:t>
-                      </a:r>
-                    </a:p>
-                  </a:txBody>
-                  <a:tcPr anchor="ctr" marL="63500" marT="12700" marB="12700">
-                    <a:solidFill>
-                      <a:srgbClr val="FFFFFF"/>
-                    </a:solidFill>
-                  </a:tcPr>
-                </a:tc>
-                <a:tc>
-                  <a:txBody>
-                    <a:bodyPr/>
-                    <a:lstStyle/>
-                    <a:p>
-                      <a:r>
-                        <a:rPr sz="1000" b="0" i="0">
-                          <a:solidFill>
-                            <a:srgbClr val="1C2736"/>
-                          </a:solidFill>
-                          <a:latin typeface="Calibri"/>
-                        </a:rPr>
-                        <a:t>~8B, 1 GPU</a:t>
-                      </a:r>
-                    </a:p>
-                  </a:txBody>
-                  <a:tcPr anchor="ctr" marL="63500" marT="12700" marB="12700">
-                    <a:solidFill>
-                      <a:srgbClr val="FFFFFF"/>
-                    </a:solidFill>
-                  </a:tcPr>
-                </a:tc>
-              </a:tr>
-              <a:tr h="329184">
-                <a:tc>
-                  <a:txBody>
-                    <a:bodyPr/>
-                    <a:lstStyle/>
-                    <a:p>
-                      <a:r>
-                        <a:rPr sz="1000" b="1" i="0">
-                          <a:solidFill>
-                            <a:srgbClr val="1C2736"/>
-                          </a:solidFill>
-                          <a:latin typeface="Calibri"/>
-                        </a:rPr>
-                        <a:t>Into 3D</a:t>
-                      </a:r>
-                    </a:p>
-                  </a:txBody>
-                  <a:tcPr anchor="ctr" marL="63500" marT="12700" marB="12700">
-                    <a:solidFill>
-                      <a:srgbClr val="E8F0F8"/>
-                    </a:solidFill>
-                  </a:tcPr>
-                </a:tc>
-                <a:tc>
-                  <a:txBody>
-                    <a:bodyPr/>
-                    <a:lstStyle/>
-                    <a:p>
-                      <a:r>
-                        <a:rPr sz="1000" b="0" i="0">
-                          <a:solidFill>
-                            <a:srgbClr val="1C2736"/>
-                          </a:solidFill>
-                          <a:latin typeface="Calibri"/>
-                        </a:rPr>
-                        <a:t>1 central slice</a:t>
-                      </a:r>
-                    </a:p>
-                  </a:txBody>
-                  <a:tcPr anchor="ctr" marL="63500" marT="12700" marB="12700">
-                    <a:solidFill>
-                      <a:srgbClr val="E8F0F8"/>
-                    </a:solidFill>
-                  </a:tcPr>
-                </a:tc>
-                <a:tc>
-                  <a:txBody>
-                    <a:bodyPr/>
-                    <a:lstStyle/>
-                    <a:p>
-                      <a:r>
-                        <a:rPr sz="1000" b="0" i="0">
-                          <a:solidFill>
-                            <a:srgbClr val="1C2736"/>
-                          </a:solidFill>
-                          <a:latin typeface="Calibri"/>
-                        </a:rPr>
-                        <a:t>multi-slice + negatives</a:t>
-                      </a:r>
-                    </a:p>
-                  </a:txBody>
-                  <a:tcPr anchor="ctr" marL="63500" marT="12700" marB="12700">
-                    <a:solidFill>
-                      <a:srgbClr val="E8F0F8"/>
-                    </a:solidFill>
-                  </a:tcPr>
-                </a:tc>
-              </a:tr>
-              <a:tr h="329184">
-                <a:tc>
-                  <a:txBody>
-                    <a:bodyPr/>
-                    <a:lstStyle/>
-                    <a:p>
-                      <a:r>
-                        <a:rPr sz="1000" b="1" i="0">
-                          <a:solidFill>
-                            <a:srgbClr val="1C2736"/>
-                          </a:solidFill>
-                          <a:latin typeface="Calibri"/>
-                        </a:rPr>
-                        <a:t>Eval unit</a:t>
-                      </a:r>
-                    </a:p>
-                  </a:txBody>
-                  <a:tcPr anchor="ctr" marL="63500" marT="12700" marB="12700">
-                    <a:solidFill>
-                      <a:srgbClr val="FFFFFF"/>
-                    </a:solidFill>
-                  </a:tcPr>
-                </a:tc>
-                <a:tc>
-                  <a:txBody>
-                    <a:bodyPr/>
-                    <a:lstStyle/>
-                    <a:p>
-                      <a:r>
-                        <a:rPr sz="1000" b="0" i="0">
-                          <a:solidFill>
-                            <a:srgbClr val="1C2736"/>
-                          </a:solidFill>
-                          <a:latin typeface="Calibri"/>
-                        </a:rPr>
-                        <a:t>per-image</a:t>
-                      </a:r>
-                    </a:p>
-                  </a:txBody>
-                  <a:tcPr anchor="ctr" marL="63500" marT="12700" marB="12700">
-                    <a:solidFill>
-                      <a:srgbClr val="FFFFFF"/>
-                    </a:solidFill>
-                  </a:tcPr>
-                </a:tc>
-                <a:tc>
-                  <a:txBody>
-                    <a:bodyPr/>
-                    <a:lstStyle/>
-                    <a:p>
-                      <a:r>
-                        <a:rPr sz="1000" b="0" i="0">
-                          <a:solidFill>
-                            <a:srgbClr val="1C2736"/>
-                          </a:solidFill>
-                          <a:latin typeface="Calibri"/>
-                        </a:rPr>
-                        <a:t>per-patient + CI</a:t>
-                      </a:r>
-                    </a:p>
-                  </a:txBody>
-                  <a:tcPr anchor="ctr" marL="63500" marT="12700" marB="12700">
-                    <a:solidFill>
-                      <a:srgbClr val="FFFFFF"/>
-                    </a:solidFill>
-                  </a:tcPr>
-                </a:tc>
-              </a:tr>
-              <a:tr h="329184">
-                <a:tc>
-                  <a:txBody>
-                    <a:bodyPr/>
-                    <a:lstStyle/>
-                    <a:p>
-                      <a:r>
-                        <a:rPr sz="1000" b="1" i="0">
-                          <a:solidFill>
-                            <a:srgbClr val="1C2736"/>
-                          </a:solidFill>
-                          <a:latin typeface="Calibri"/>
-                        </a:rPr>
-                        <a:t>Detect vs Localize</a:t>
-                      </a:r>
-                    </a:p>
-                  </a:txBody>
-                  <a:tcPr anchor="ctr" marL="63500" marT="12700" marB="12700">
-                    <a:solidFill>
-                      <a:srgbClr val="E8F0F8"/>
-                    </a:solidFill>
-                  </a:tcPr>
-                </a:tc>
-                <a:tc>
-                  <a:txBody>
-                    <a:bodyPr/>
-                    <a:lstStyle/>
-                    <a:p>
-                      <a:r>
-                        <a:rPr sz="1000" b="0" i="0">
-                          <a:solidFill>
-                            <a:srgbClr val="1C2736"/>
-                          </a:solidFill>
-                          <a:latin typeface="Calibri"/>
-                        </a:rPr>
-                        <a:t>merged</a:t>
-                      </a:r>
-                    </a:p>
-                  </a:txBody>
-                  <a:tcPr anchor="ctr" marL="63500" marT="12700" marB="12700">
-                    <a:solidFill>
-                      <a:srgbClr val="E8F0F8"/>
-                    </a:solidFill>
-                  </a:tcPr>
-                </a:tc>
-                <a:tc>
-                  <a:txBody>
-                    <a:bodyPr/>
-                    <a:lstStyle/>
-                    <a:p>
-                      <a:r>
-                        <a:rPr sz="1000" b="0" i="0">
-                          <a:solidFill>
-                            <a:srgbClr val="1C2736"/>
-                          </a:solidFill>
-                          <a:latin typeface="Calibri"/>
-                        </a:rPr>
-                        <a:t>separated</a:t>
-                      </a:r>
-                    </a:p>
-                  </a:txBody>
-                  <a:tcPr anchor="ctr" marL="63500" marT="12700" marB="12700">
-                    <a:solidFill>
-                      <a:srgbClr val="E8F0F8"/>
-                    </a:solidFill>
-                  </a:tcPr>
-                </a:tc>
-              </a:tr>
-              <a:tr h="329184">
-                <a:tc>
-                  <a:txBody>
-                    <a:bodyPr/>
-                    <a:lstStyle/>
-                    <a:p>
-                      <a:r>
-                        <a:rPr sz="1000" b="1" i="0">
-                          <a:solidFill>
-                            <a:srgbClr val="1C2736"/>
-                          </a:solidFill>
-                          <a:latin typeface="Calibri"/>
-                        </a:rPr>
-                        <a:t>Negatives / Uncertainty</a:t>
-                      </a:r>
-                    </a:p>
-                  </a:txBody>
-                  <a:tcPr anchor="ctr" marL="63500" marT="12700" marB="12700">
-                    <a:solidFill>
-                      <a:srgbClr val="FFFFFF"/>
-                    </a:solidFill>
-                  </a:tcPr>
-                </a:tc>
-                <a:tc>
-                  <a:txBody>
-                    <a:bodyPr/>
-                    <a:lstStyle/>
-                    <a:p>
-                      <a:r>
-                        <a:rPr sz="1000" b="0" i="0">
-                          <a:solidFill>
-                            <a:srgbClr val="1C2736"/>
-                          </a:solidFill>
-                          <a:latin typeface="Calibri"/>
-                        </a:rPr>
-                        <a:t>none</a:t>
-                      </a:r>
-                    </a:p>
-                  </a:txBody>
-                  <a:tcPr anchor="ctr" marL="63500" marT="12700" marB="12700">
-                    <a:solidFill>
-                      <a:srgbClr val="FFFFFF"/>
-                    </a:solidFill>
-                  </a:tcPr>
-                </a:tc>
-                <a:tc>
-                  <a:txBody>
-                    <a:bodyPr/>
-                    <a:lstStyle/>
-                    <a:p>
-                      <a:r>
-                        <a:rPr sz="1000" b="0" i="0">
-                          <a:solidFill>
-                            <a:srgbClr val="1C2736"/>
-                          </a:solidFill>
-                          <a:latin typeface="Calibri"/>
-                        </a:rPr>
-                        <a:t>FP + selective prediction</a:t>
-                      </a:r>
-                    </a:p>
-                  </a:txBody>
-                  <a:tcPr anchor="ctr" marL="63500" marT="12700" marB="12700">
-                    <a:solidFill>
-                      <a:srgbClr val="FFFFFF"/>
-                    </a:solidFill>
-                  </a:tcPr>
-                </a:tc>
-              </a:tr>
-              <a:tr h="329184">
-                <a:tc>
-                  <a:txBody>
-                    <a:bodyPr/>
-                    <a:lstStyle/>
-                    <a:p>
-                      <a:r>
-                        <a:rPr sz="1000" b="1" i="0">
-                          <a:solidFill>
-                            <a:srgbClr val="1C2736"/>
-                          </a:solidFill>
-                          <a:latin typeface="Calibri"/>
-                        </a:rPr>
-                        <a:t>Localization</a:t>
-                      </a:r>
-                    </a:p>
-                  </a:txBody>
-                  <a:tcPr anchor="ctr" marL="63500" marT="12700" marB="12700">
-                    <a:solidFill>
-                      <a:srgbClr val="E8F0F8"/>
-                    </a:solidFill>
-                  </a:tcPr>
-                </a:tc>
-                <a:tc>
-                  <a:txBody>
-                    <a:bodyPr/>
-                    <a:lstStyle/>
-                    <a:p>
-                      <a:r>
-                        <a:rPr sz="1000" b="0" i="0">
-                          <a:solidFill>
-                            <a:srgbClr val="1C2736"/>
-                          </a:solidFill>
-                          <a:latin typeface="Calibri"/>
-                        </a:rPr>
-                        <a:t>IoU ~0.23</a:t>
-                      </a:r>
-                    </a:p>
-                  </a:txBody>
-                  <a:tcPr anchor="ctr" marL="63500" marT="12700" marB="12700">
-                    <a:solidFill>
-                      <a:srgbClr val="E8F0F8"/>
-                    </a:solidFill>
-                  </a:tcPr>
-                </a:tc>
-                <a:tc>
-                  <a:txBody>
-                    <a:bodyPr/>
-                    <a:lstStyle/>
-                    <a:p>
-                      <a:r>
-                        <a:rPr sz="1000" b="0" i="0">
-                          <a:solidFill>
-                            <a:srgbClr val="1C2736"/>
-                          </a:solidFill>
-                          <a:latin typeface="Calibri"/>
-                        </a:rPr>
-                        <a:t>pIoU ~0.27</a:t>
-                      </a:r>
-                    </a:p>
-                  </a:txBody>
-                  <a:tcPr anchor="ctr" marL="63500" marT="12700" marB="12700">
-                    <a:solidFill>
-                      <a:srgbClr val="E8F0F8"/>
-                    </a:solidFill>
-                  </a:tcPr>
-                </a:tc>
-              </a:tr>
-            </a:tbl>
-          </a:graphicData>
-        </a:graphic>
-      </p:graphicFrame>
-      <p:sp>
-        <p:nvSpPr>
-          <p:cNvPr id="5" name="Rectangle 4"/>
+        </p:nvSpPr>
+        <p:spPr>
+          <a:xfrm>
+            <a:off x="338328" y="694944"/>
+            <a:ext cx="8412480" cy="411480"/>
+          </a:xfrm>
+          <a:prstGeom prst="rect">
+            <a:avLst/>
+          </a:prstGeom>
+          <a:noFill/>
+        </p:spPr>
+        <p:txBody>
+          <a:bodyPr wrap="square" anchor="t" lIns="25400" rIns="25400" tIns="12700" bIns="12700">
+            <a:spAutoFit/>
+          </a:bodyPr>
+          <a:lstStyle/>
+          <a:p>
+            <a:r>
+              <a:rPr sz="1150" b="0" i="1">
+                <a:solidFill>
+                  <a:srgbClr val="B8CFE0"/>
+                </a:solidFill>
+                <a:latin typeface="Calibri"/>
+              </a:rPr>
+              <a:t>Not just a model swap: zero-shot (new model, untrained) → fine-tuned</a:t>
+            </a:r>
+          </a:p>
+        </p:txBody>
+      </p:sp>
+      <p:sp>
+        <p:nvSpPr>
+          <p:cNvPr id="5" name="TextBox 4"/>
+          <p:cNvSpPr txBox="1"/>
+          <p:nvPr/>
+        </p:nvSpPr>
+        <p:spPr>
+          <a:xfrm>
+            <a:off x="365760" y="1417320"/>
+            <a:ext cx="5029200" cy="2743200"/>
+          </a:xfrm>
+          <a:prstGeom prst="rect">
+            <a:avLst/>
+          </a:prstGeom>
+          <a:noFill/>
+        </p:spPr>
+        <p:txBody>
+          <a:bodyPr wrap="square" anchor="t" lIns="25400" rIns="25400" tIns="12700" bIns="12700">
+            <a:spAutoFit/>
+          </a:bodyPr>
+          <a:lstStyle/>
+          <a:p>
+            <a:pPr>
+              <a:spcBef>
+                <a:spcPts val="0"/>
+              </a:spcBef>
+              <a:spcAft>
+                <a:spcPts val="1200"/>
+              </a:spcAft>
+            </a:pPr>
+            <a:r>
+              <a:rPr sz="1300" b="1" i="0">
+                <a:solidFill>
+                  <a:srgbClr val="1A3A5C"/>
+                </a:solidFill>
+                <a:latin typeface="Calibri"/>
+              </a:rPr>
+              <a:t>▪  </a:t>
+            </a:r>
+            <a:r>
+              <a:rPr sz="1300" b="1" i="0">
+                <a:solidFill>
+                  <a:srgbClr val="1C2736"/>
+                </a:solidFill>
+                <a:latin typeface="Calibri"/>
+              </a:rPr>
+              <a:t>Swapping models alone is NOT enough:</a:t>
+            </a:r>
+            <a:r>
+              <a:rPr sz="1300" b="0" i="0">
+                <a:solidFill>
+                  <a:srgbClr val="1C2736"/>
+                </a:solidFill>
+                <a:latin typeface="Calibri"/>
+              </a:rPr>
+              <a:t> zero-shot Gemma (untrained) scores only </a:t>
+            </a:r>
+            <a:r>
+              <a:rPr sz="1300" b="1" i="0">
+                <a:solidFill>
+                  <a:srgbClr val="1C2736"/>
+                </a:solidFill>
+                <a:latin typeface="Calibri"/>
+              </a:rPr>
+              <a:t>F1 0.33</a:t>
+            </a:r>
+            <a:r>
+              <a:rPr sz="1300" b="0" i="0">
+                <a:solidFill>
+                  <a:srgbClr val="1C2736"/>
+                </a:solidFill>
+                <a:latin typeface="Calibri"/>
+              </a:rPr>
+              <a:t>, almost always says “No tumor”.</a:t>
+            </a:r>
+          </a:p>
+          <a:p>
+            <a:pPr>
+              <a:spcBef>
+                <a:spcPts val="0"/>
+              </a:spcBef>
+              <a:spcAft>
+                <a:spcPts val="1200"/>
+              </a:spcAft>
+            </a:pPr>
+            <a:r>
+              <a:rPr sz="1300" b="1" i="0">
+                <a:solidFill>
+                  <a:srgbClr val="1A3A5C"/>
+                </a:solidFill>
+                <a:latin typeface="Calibri"/>
+              </a:rPr>
+              <a:t>▪  </a:t>
+            </a:r>
+            <a:r>
+              <a:rPr sz="1300" b="1" i="0">
+                <a:solidFill>
+                  <a:srgbClr val="1C2736"/>
+                </a:solidFill>
+                <a:latin typeface="Calibri"/>
+              </a:rPr>
+              <a:t>Fine-tuning creates the capability:</a:t>
+            </a:r>
+            <a:r>
+              <a:rPr sz="1300" b="0" i="0">
+                <a:solidFill>
+                  <a:srgbClr val="1C2736"/>
+                </a:solidFill>
+                <a:latin typeface="Calibri"/>
+              </a:rPr>
+              <a:t> F1 0.33→</a:t>
+            </a:r>
+            <a:r>
+              <a:rPr sz="1300" b="1" i="0">
+                <a:solidFill>
+                  <a:srgbClr val="1C2736"/>
+                </a:solidFill>
+                <a:latin typeface="Calibri"/>
+              </a:rPr>
+              <a:t>0.89</a:t>
+            </a:r>
+            <a:r>
+              <a:rPr sz="1300" b="0" i="0">
+                <a:solidFill>
+                  <a:srgbClr val="1C2736"/>
+                </a:solidFill>
+                <a:latin typeface="Calibri"/>
+              </a:rPr>
+              <a:t>, recall 0→</a:t>
+            </a:r>
+            <a:r>
+              <a:rPr sz="1300" b="1" i="0">
+                <a:solidFill>
+                  <a:srgbClr val="1C2736"/>
+                </a:solidFill>
+                <a:latin typeface="Calibri"/>
+              </a:rPr>
+              <a:t>54%</a:t>
+            </a:r>
+            <a:r>
+              <a:rPr sz="1300" b="0" i="0">
+                <a:solidFill>
+                  <a:srgbClr val="1C2736"/>
+                </a:solidFill>
+                <a:latin typeface="Calibri"/>
+              </a:rPr>
+              <a:t>, pIoU 0.002→</a:t>
+            </a:r>
+            <a:r>
+              <a:rPr sz="1300" b="1" i="0">
+                <a:solidFill>
+                  <a:srgbClr val="1C2736"/>
+                </a:solidFill>
+                <a:latin typeface="Calibri"/>
+              </a:rPr>
+              <a:t>0.27</a:t>
+            </a:r>
+            <a:r>
+              <a:rPr sz="1300" b="0" i="0">
+                <a:solidFill>
+                  <a:srgbClr val="1C2736"/>
+                </a:solidFill>
+                <a:latin typeface="Calibri"/>
+              </a:rPr>
+              <a:t>.</a:t>
+            </a:r>
+          </a:p>
+          <a:p>
+            <a:pPr>
+              <a:spcBef>
+                <a:spcPts val="0"/>
+              </a:spcBef>
+              <a:spcAft>
+                <a:spcPts val="1200"/>
+              </a:spcAft>
+            </a:pPr>
+            <a:r>
+              <a:rPr sz="1300" b="1" i="0">
+                <a:solidFill>
+                  <a:srgbClr val="1A3A5C"/>
+                </a:solidFill>
+                <a:latin typeface="Calibri"/>
+              </a:rPr>
+              <a:t>▪  </a:t>
+            </a:r>
+            <a:r>
+              <a:rPr sz="1300" b="1" i="0">
+                <a:solidFill>
+                  <a:srgbClr val="1C2736"/>
+                </a:solidFill>
+                <a:latin typeface="Calibri"/>
+              </a:rPr>
+              <a:t>Extra evidence:</a:t>
+            </a:r>
+            <a:r>
+              <a:rPr sz="1300" b="0" i="0">
+                <a:solidFill>
+                  <a:srgbClr val="1C2736"/>
+                </a:solidFill>
+                <a:latin typeface="Calibri"/>
+              </a:rPr>
+              <a:t> frozen vision → pIoU 0.015; </a:t>
+            </a:r>
+            <a:r>
+              <a:rPr sz="1300" b="1" i="0">
+                <a:solidFill>
+                  <a:srgbClr val="1C2736"/>
+                </a:solidFill>
+                <a:latin typeface="Calibri"/>
+              </a:rPr>
+              <a:t>unlock + train → 0.27</a:t>
+            </a:r>
+            <a:r>
+              <a:rPr sz="1300" b="0" i="0">
+                <a:solidFill>
+                  <a:srgbClr val="1C2736"/>
+                </a:solidFill>
+                <a:latin typeface="Calibri"/>
+              </a:rPr>
+              <a:t> — the training choice is the key.</a:t>
+            </a:r>
+          </a:p>
+        </p:txBody>
+      </p:sp>
+      <p:pic>
+        <p:nvPicPr>
+          <p:cNvPr id="6" name="Picture 5" descr="detect_before_after_en.png"/>
+          <p:cNvPicPr>
+            <a:picLocks noChangeAspect="1"/>
+          </p:cNvPicPr>
+          <p:nvPr/>
+        </p:nvPicPr>
+        <p:blipFill>
+          <a:blip r:embed="rId2"/>
+          <a:stretch>
+            <a:fillRect/>
+          </a:stretch>
+        </p:blipFill>
+        <p:spPr>
+          <a:xfrm>
+            <a:off x="5577840" y="1508760"/>
+            <a:ext cx="3383280" cy="1953725"/>
+          </a:xfrm>
+          <a:prstGeom prst="rect">
+            <a:avLst/>
+          </a:prstGeom>
+        </p:spPr>
+      </p:pic>
+      <p:sp>
+        <p:nvSpPr>
+          <p:cNvPr id="7" name="TextBox 6"/>
+          <p:cNvSpPr txBox="1"/>
+          <p:nvPr/>
+        </p:nvSpPr>
+        <p:spPr>
+          <a:xfrm>
+            <a:off x="5577840" y="3489916"/>
+            <a:ext cx="3383280" cy="274320"/>
+          </a:xfrm>
+          <a:prstGeom prst="rect">
+            <a:avLst/>
+          </a:prstGeom>
+          <a:noFill/>
+        </p:spPr>
+        <p:txBody>
+          <a:bodyPr wrap="square" anchor="t" lIns="25400" rIns="25400" tIns="12700" bIns="12700">
+            <a:spAutoFit/>
+          </a:bodyPr>
+          <a:lstStyle/>
+          <a:p>
+            <a:pPr algn="ctr"/>
+            <a:r>
+              <a:rPr sz="800" b="0" i="1">
+                <a:solidFill>
+                  <a:srgbClr val="6B7F95"/>
+                </a:solidFill>
+                <a:latin typeface="Calibri"/>
+              </a:rPr>
+              <a:t>Before → after fine-tune</a:t>
+            </a:r>
+          </a:p>
+        </p:txBody>
+      </p:sp>
+      <p:sp>
+        <p:nvSpPr>
+          <p:cNvPr id="8" name="Rectangle 7"/>
           <p:cNvSpPr/>
           <p:nvPr/>
         </p:nvSpPr>
         <p:spPr>
           <a:xfrm>
-            <a:off x="5989320" y="1115568"/>
-            <a:ext cx="2834640" cy="2194560"/>
+            <a:off x="365760" y="4069080"/>
+            <a:ext cx="5029200" cy="658368"/>
           </a:xfrm>
           <a:prstGeom prst="rect">
             <a:avLst/>
@@ -5494,14 +5291,14 @@
       </p:sp>
       <p:sp>
         <p:nvSpPr>
-          <p:cNvPr id="6" name="TextBox 5"/>
+          <p:cNvPr id="9" name="TextBox 8"/>
           <p:cNvSpPr txBox="1"/>
           <p:nvPr/>
         </p:nvSpPr>
         <p:spPr>
           <a:xfrm>
-            <a:off x="6099048" y="1179576"/>
-            <a:ext cx="2615184" cy="2066543"/>
+            <a:off x="475488" y="4133088"/>
+            <a:ext cx="4809744" cy="530352"/>
           </a:xfrm>
           <a:prstGeom prst="rect">
             <a:avLst/>
@@ -5521,7 +5318,7 @@
                 </a:solidFill>
                 <a:latin typeface="Calibri"/>
               </a:rPr>
-              <a:t>Read it correctly</a:t>
+              <a:t>Takeaway</a:t>
             </a:r>
           </a:p>
           <a:p>
@@ -5537,14 +5334,14 @@
                 </a:solidFill>
                 <a:latin typeface="Calibri"/>
               </a:rPr>
-              <a:t>NOT a direct number match (different data/metric); pIoU is PENALIZED, so stricter. Real contribution = honest evaluation + reliability layer.</a:t>
-            </a:r>
-          </a:p>
-        </p:txBody>
-      </p:sp>
-      <p:sp>
-        <p:nvSpPr>
-          <p:cNvPr id="7" name="Rectangle 6"/>
+              <a:t>The gains come from FINE-TUNING (data + unlocked vision + eval), not from a newer model.</a:t>
+            </a:r>
+          </a:p>
+        </p:txBody>
+      </p:sp>
+      <p:sp>
+        <p:nvSpPr>
+          <p:cNvPr id="10" name="Rectangle 9"/>
           <p:cNvSpPr/>
           <p:nvPr/>
         </p:nvSpPr>
@@ -5588,7 +5385,7 @@
       </p:sp>
       <p:sp>
         <p:nvSpPr>
-          <p:cNvPr id="8" name="TextBox 7"/>
+          <p:cNvPr id="11" name="TextBox 10"/>
           <p:cNvSpPr txBox="1"/>
           <p:nvPr/>
         </p:nvSpPr>
@@ -5622,7 +5419,7 @@
       </p:sp>
       <p:sp>
         <p:nvSpPr>
-          <p:cNvPr id="9" name="TextBox 8"/>
+          <p:cNvPr id="12" name="TextBox 11"/>
           <p:cNvSpPr txBox="1"/>
           <p:nvPr/>
         </p:nvSpPr>

</xml_diff>

<commit_message>
cai_tien: fix build_5min thiếu helper notes() — speaker notes S3 đã vào deck
Co-Authored-By: Claude Opus 4.8 <noreply@anthropic.com>
</commit_message>
<xml_diff>
--- a/seminar/cai_tien/slides_5min_EN.pptx
+++ b/seminar/cai_tien/slides_5min_EN.pptx
@@ -8,8 +8,8 @@
     <p:sldId id="256" r:id="rId7"/>
     <p:sldId id="257" r:id="rId8"/>
     <p:sldId id="258" r:id="rId9"/>
-    <p:sldId id="259" r:id="rId10"/>
-    <p:sldId id="260" r:id="rId11"/>
+    <p:sldId id="259" r:id="rId11"/>
+    <p:sldId id="260" r:id="rId12"/>
   </p:sldIdLst>
   <p:sldSz cx="9144000" cy="5143500" type="screen4x3"/>
   <p:notesSz cx="6858000" cy="9144000"/>
@@ -109,6 +109,478 @@
     </a:lvl9pPr>
   </p:defaultTextStyle>
 </p:presentation>
+</file>
+
+<file path=ppt/notesMasters/notesMaster1.xml><?xml version="1.0" encoding="utf-8"?>
+<p:notesMaster xmlns:a="http://schemas.openxmlformats.org/drawingml/2006/main" xmlns:p="http://schemas.openxmlformats.org/presentationml/2006/main" xmlns:r="http://schemas.openxmlformats.org/officeDocument/2006/relationships">
+  <p:cSld>
+    <p:bg>
+      <p:bgRef idx="1001">
+        <a:schemeClr val="bg1"/>
+      </p:bgRef>
+    </p:bg>
+    <p:spTree>
+      <p:nvGrpSpPr>
+        <p:cNvPr id="1" name=""/>
+        <p:cNvGrpSpPr/>
+        <p:nvPr/>
+      </p:nvGrpSpPr>
+      <p:grpSpPr>
+        <a:xfrm>
+          <a:off x="0" y="0"/>
+          <a:ext cx="0" cy="0"/>
+          <a:chOff x="0" y="0"/>
+          <a:chExt cx="0" cy="0"/>
+        </a:xfrm>
+      </p:grpSpPr>
+      <p:sp>
+        <p:nvSpPr>
+          <p:cNvPr id="2" name="Header Placeholder 1"/>
+          <p:cNvSpPr>
+            <a:spLocks noGrp="1"/>
+          </p:cNvSpPr>
+          <p:nvPr>
+            <p:ph type="hdr" sz="quarter"/>
+          </p:nvPr>
+        </p:nvSpPr>
+        <p:spPr>
+          <a:xfrm>
+            <a:off x="0" y="0"/>
+            <a:ext cx="2971800" cy="457200"/>
+          </a:xfrm>
+          <a:prstGeom prst="rect">
+            <a:avLst/>
+          </a:prstGeom>
+        </p:spPr>
+        <p:txBody>
+          <a:bodyPr vert="horz" lIns="91440" tIns="45720" rIns="91440" bIns="45720" rtlCol="0"/>
+          <a:lstStyle>
+            <a:lvl1pPr algn="l">
+              <a:defRPr sz="1200"/>
+            </a:lvl1pPr>
+          </a:lstStyle>
+          <a:p>
+            <a:endParaRPr lang="en-US"/>
+          </a:p>
+        </p:txBody>
+      </p:sp>
+      <p:sp>
+        <p:nvSpPr>
+          <p:cNvPr id="3" name="Date Placeholder 2"/>
+          <p:cNvSpPr>
+            <a:spLocks noGrp="1"/>
+          </p:cNvSpPr>
+          <p:nvPr>
+            <p:ph type="dt" idx="1"/>
+          </p:nvPr>
+        </p:nvSpPr>
+        <p:spPr>
+          <a:xfrm>
+            <a:off x="3884613" y="0"/>
+            <a:ext cx="2971800" cy="457200"/>
+          </a:xfrm>
+          <a:prstGeom prst="rect">
+            <a:avLst/>
+          </a:prstGeom>
+        </p:spPr>
+        <p:txBody>
+          <a:bodyPr vert="horz" lIns="91440" tIns="45720" rIns="91440" bIns="45720" rtlCol="0"/>
+          <a:lstStyle>
+            <a:lvl1pPr algn="r">
+              <a:defRPr sz="1200"/>
+            </a:lvl1pPr>
+          </a:lstStyle>
+          <a:p>
+            <a:fld id="{0F89C1C7-3DCD-1040-A9CF-14679D8B5DDD}" type="datetimeFigureOut">
+              <a:rPr lang="en-US" smtClean="0"/>
+              <a:t>10/17/16</a:t>
+            </a:fld>
+            <a:endParaRPr lang="en-US"/>
+          </a:p>
+        </p:txBody>
+      </p:sp>
+      <p:sp>
+        <p:nvSpPr>
+          <p:cNvPr id="4" name="Slide Image Placeholder 3"/>
+          <p:cNvSpPr>
+            <a:spLocks noGrp="1" noRot="1" noChangeAspect="1"/>
+          </p:cNvSpPr>
+          <p:nvPr>
+            <p:ph type="sldImg" idx="2"/>
+          </p:nvPr>
+        </p:nvSpPr>
+        <p:spPr>
+          <a:xfrm>
+            <a:off x="1143000" y="685800"/>
+            <a:ext cx="4572000" cy="3429000"/>
+          </a:xfrm>
+          <a:prstGeom prst="rect">
+            <a:avLst/>
+          </a:prstGeom>
+          <a:noFill/>
+          <a:ln w="12700">
+            <a:solidFill>
+              <a:prstClr val="black"/>
+            </a:solidFill>
+          </a:ln>
+        </p:spPr>
+        <p:txBody>
+          <a:bodyPr vert="horz" lIns="91440" tIns="45720" rIns="91440" bIns="45720" rtlCol="0" anchor="ctr"/>
+          <a:lstStyle/>
+          <a:p>
+            <a:endParaRPr lang="en-US"/>
+          </a:p>
+        </p:txBody>
+      </p:sp>
+      <p:sp>
+        <p:nvSpPr>
+          <p:cNvPr id="5" name="Notes Placeholder 4"/>
+          <p:cNvSpPr>
+            <a:spLocks noGrp="1"/>
+          </p:cNvSpPr>
+          <p:nvPr>
+            <p:ph type="body" sz="quarter" idx="3"/>
+          </p:nvPr>
+        </p:nvSpPr>
+        <p:spPr>
+          <a:xfrm>
+            <a:off x="685800" y="4343400"/>
+            <a:ext cx="5486400" cy="4114800"/>
+          </a:xfrm>
+          <a:prstGeom prst="rect">
+            <a:avLst/>
+          </a:prstGeom>
+        </p:spPr>
+        <p:txBody>
+          <a:bodyPr vert="horz" lIns="91440" tIns="45720" rIns="91440" bIns="45720" rtlCol="0"/>
+          <a:lstStyle/>
+          <a:p>
+            <a:pPr lvl="0"/>
+            <a:r>
+              <a:rPr lang="en-US" smtClean="0"/>
+              <a:t>Click to edit Master text styles</a:t>
+            </a:r>
+          </a:p>
+          <a:p>
+            <a:pPr lvl="1"/>
+            <a:r>
+              <a:rPr lang="en-US" smtClean="0"/>
+              <a:t>Second level</a:t>
+            </a:r>
+          </a:p>
+          <a:p>
+            <a:pPr lvl="2"/>
+            <a:r>
+              <a:rPr lang="en-US" smtClean="0"/>
+              <a:t>Third level</a:t>
+            </a:r>
+          </a:p>
+          <a:p>
+            <a:pPr lvl="3"/>
+            <a:r>
+              <a:rPr lang="en-US" smtClean="0"/>
+              <a:t>Fourth level</a:t>
+            </a:r>
+          </a:p>
+          <a:p>
+            <a:pPr lvl="4"/>
+            <a:r>
+              <a:rPr lang="en-US" smtClean="0"/>
+              <a:t>Fifth level</a:t>
+            </a:r>
+            <a:endParaRPr lang="en-US"/>
+          </a:p>
+        </p:txBody>
+      </p:sp>
+      <p:sp>
+        <p:nvSpPr>
+          <p:cNvPr id="6" name="Footer Placeholder 5"/>
+          <p:cNvSpPr>
+            <a:spLocks noGrp="1"/>
+          </p:cNvSpPr>
+          <p:nvPr>
+            <p:ph type="ftr" sz="quarter" idx="4"/>
+          </p:nvPr>
+        </p:nvSpPr>
+        <p:spPr>
+          <a:xfrm>
+            <a:off x="0" y="8685213"/>
+            <a:ext cx="2971800" cy="457200"/>
+          </a:xfrm>
+          <a:prstGeom prst="rect">
+            <a:avLst/>
+          </a:prstGeom>
+        </p:spPr>
+        <p:txBody>
+          <a:bodyPr vert="horz" lIns="91440" tIns="45720" rIns="91440" bIns="45720" rtlCol="0" anchor="b"/>
+          <a:lstStyle>
+            <a:lvl1pPr algn="l">
+              <a:defRPr sz="1200"/>
+            </a:lvl1pPr>
+          </a:lstStyle>
+          <a:p>
+            <a:endParaRPr lang="en-US"/>
+          </a:p>
+        </p:txBody>
+      </p:sp>
+      <p:sp>
+        <p:nvSpPr>
+          <p:cNvPr id="7" name="Slide Number Placeholder 6"/>
+          <p:cNvSpPr>
+            <a:spLocks noGrp="1"/>
+          </p:cNvSpPr>
+          <p:nvPr>
+            <p:ph type="sldNum" sz="quarter" idx="5"/>
+          </p:nvPr>
+        </p:nvSpPr>
+        <p:spPr>
+          <a:xfrm>
+            <a:off x="3884613" y="8685213"/>
+            <a:ext cx="2971800" cy="457200"/>
+          </a:xfrm>
+          <a:prstGeom prst="rect">
+            <a:avLst/>
+          </a:prstGeom>
+        </p:spPr>
+        <p:txBody>
+          <a:bodyPr vert="horz" lIns="91440" tIns="45720" rIns="91440" bIns="45720" rtlCol="0" anchor="b"/>
+          <a:lstStyle>
+            <a:lvl1pPr algn="r">
+              <a:defRPr sz="1200"/>
+            </a:lvl1pPr>
+          </a:lstStyle>
+          <a:p>
+            <a:fld id="{BB5E49A5-4136-284D-997B-48E1D791AD67}" type="slidenum">
+              <a:rPr lang="en-US" smtClean="0"/>
+              <a:t>‹#›</a:t>
+            </a:fld>
+            <a:endParaRPr lang="en-US"/>
+          </a:p>
+        </p:txBody>
+      </p:sp>
+    </p:spTree>
+    <p:extLst>
+      <p:ext uri="{BB962C8B-B14F-4D97-AF65-F5344CB8AC3E}">
+        <p14:creationId xmlns:p14="http://schemas.microsoft.com/office/powerpoint/2010/main" val="2623252185"/>
+      </p:ext>
+    </p:extLst>
+  </p:cSld>
+  <p:clrMap bg1="lt1" tx1="dk1" bg2="lt2" tx2="dk2" accent1="accent1" accent2="accent2" accent3="accent3" accent4="accent4" accent5="accent5" accent6="accent6" hlink="hlink" folHlink="folHlink"/>
+  <p:notesStyle>
+    <a:lvl1pPr marL="0" algn="l" defTabSz="457200" rtl="0" eaLnBrk="1" latinLnBrk="0" hangingPunct="1">
+      <a:defRPr sz="1200" kern="1200">
+        <a:solidFill>
+          <a:schemeClr val="tx1"/>
+        </a:solidFill>
+        <a:latin typeface="+mn-lt"/>
+        <a:ea typeface="+mn-ea"/>
+        <a:cs typeface="+mn-cs"/>
+      </a:defRPr>
+    </a:lvl1pPr>
+    <a:lvl2pPr marL="457200" algn="l" defTabSz="457200" rtl="0" eaLnBrk="1" latinLnBrk="0" hangingPunct="1">
+      <a:defRPr sz="1200" kern="1200">
+        <a:solidFill>
+          <a:schemeClr val="tx1"/>
+        </a:solidFill>
+        <a:latin typeface="+mn-lt"/>
+        <a:ea typeface="+mn-ea"/>
+        <a:cs typeface="+mn-cs"/>
+      </a:defRPr>
+    </a:lvl2pPr>
+    <a:lvl3pPr marL="914400" algn="l" defTabSz="457200" rtl="0" eaLnBrk="1" latinLnBrk="0" hangingPunct="1">
+      <a:defRPr sz="1200" kern="1200">
+        <a:solidFill>
+          <a:schemeClr val="tx1"/>
+        </a:solidFill>
+        <a:latin typeface="+mn-lt"/>
+        <a:ea typeface="+mn-ea"/>
+        <a:cs typeface="+mn-cs"/>
+      </a:defRPr>
+    </a:lvl3pPr>
+    <a:lvl4pPr marL="1371600" algn="l" defTabSz="457200" rtl="0" eaLnBrk="1" latinLnBrk="0" hangingPunct="1">
+      <a:defRPr sz="1200" kern="1200">
+        <a:solidFill>
+          <a:schemeClr val="tx1"/>
+        </a:solidFill>
+        <a:latin typeface="+mn-lt"/>
+        <a:ea typeface="+mn-ea"/>
+        <a:cs typeface="+mn-cs"/>
+      </a:defRPr>
+    </a:lvl4pPr>
+    <a:lvl5pPr marL="1828800" algn="l" defTabSz="457200" rtl="0" eaLnBrk="1" latinLnBrk="0" hangingPunct="1">
+      <a:defRPr sz="1200" kern="1200">
+        <a:solidFill>
+          <a:schemeClr val="tx1"/>
+        </a:solidFill>
+        <a:latin typeface="+mn-lt"/>
+        <a:ea typeface="+mn-ea"/>
+        <a:cs typeface="+mn-cs"/>
+      </a:defRPr>
+    </a:lvl5pPr>
+    <a:lvl6pPr marL="2286000" algn="l" defTabSz="457200" rtl="0" eaLnBrk="1" latinLnBrk="0" hangingPunct="1">
+      <a:defRPr sz="1200" kern="1200">
+        <a:solidFill>
+          <a:schemeClr val="tx1"/>
+        </a:solidFill>
+        <a:latin typeface="+mn-lt"/>
+        <a:ea typeface="+mn-ea"/>
+        <a:cs typeface="+mn-cs"/>
+      </a:defRPr>
+    </a:lvl6pPr>
+    <a:lvl7pPr marL="2743200" algn="l" defTabSz="457200" rtl="0" eaLnBrk="1" latinLnBrk="0" hangingPunct="1">
+      <a:defRPr sz="1200" kern="1200">
+        <a:solidFill>
+          <a:schemeClr val="tx1"/>
+        </a:solidFill>
+        <a:latin typeface="+mn-lt"/>
+        <a:ea typeface="+mn-ea"/>
+        <a:cs typeface="+mn-cs"/>
+      </a:defRPr>
+    </a:lvl7pPr>
+    <a:lvl8pPr marL="3200400" algn="l" defTabSz="457200" rtl="0" eaLnBrk="1" latinLnBrk="0" hangingPunct="1">
+      <a:defRPr sz="1200" kern="1200">
+        <a:solidFill>
+          <a:schemeClr val="tx1"/>
+        </a:solidFill>
+        <a:latin typeface="+mn-lt"/>
+        <a:ea typeface="+mn-ea"/>
+        <a:cs typeface="+mn-cs"/>
+      </a:defRPr>
+    </a:lvl8pPr>
+    <a:lvl9pPr marL="3657600" algn="l" defTabSz="457200" rtl="0" eaLnBrk="1" latinLnBrk="0" hangingPunct="1">
+      <a:defRPr sz="1200" kern="1200">
+        <a:solidFill>
+          <a:schemeClr val="tx1"/>
+        </a:solidFill>
+        <a:latin typeface="+mn-lt"/>
+        <a:ea typeface="+mn-ea"/>
+        <a:cs typeface="+mn-cs"/>
+      </a:defRPr>
+    </a:lvl9pPr>
+  </p:notesStyle>
+</p:notesMaster>
+</file>
+
+<file path=ppt/notesSlides/notesSlide1.xml><?xml version="1.0" encoding="utf-8"?>
+<p:notes xmlns:a="http://schemas.openxmlformats.org/drawingml/2006/main" xmlns:p="http://schemas.openxmlformats.org/presentationml/2006/main" xmlns:r="http://schemas.openxmlformats.org/officeDocument/2006/relationships">
+  <p:cSld>
+    <p:spTree>
+      <p:nvGrpSpPr>
+        <p:cNvPr id="1" name=""/>
+        <p:cNvGrpSpPr/>
+        <p:nvPr/>
+      </p:nvGrpSpPr>
+      <p:grpSpPr>
+        <a:xfrm>
+          <a:off x="0" y="0"/>
+          <a:ext cx="0" cy="0"/>
+          <a:chOff x="0" y="0"/>
+          <a:chExt cx="0" cy="0"/>
+        </a:xfrm>
+      </p:grpSpPr>
+      <p:sp>
+        <p:nvSpPr>
+          <p:cNvPr id="2" name="Slide Image Placeholder 1"/>
+          <p:cNvSpPr>
+            <a:spLocks noGrp="1"/>
+          </p:cNvSpPr>
+          <p:nvPr>
+            <p:ph type="sldImg" idx="2"/>
+          </p:nvPr>
+        </p:nvSpPr>
+        <p:spPr/>
+      </p:sp>
+      <p:sp>
+        <p:nvSpPr>
+          <p:cNvPr id="3" name="Notes Placeholder 2"/>
+          <p:cNvSpPr>
+            <a:spLocks noGrp="1"/>
+          </p:cNvSpPr>
+          <p:nvPr>
+            <p:ph type="body" idx="3" sz="quarter"/>
+          </p:nvPr>
+        </p:nvSpPr>
+        <p:spPr/>
+        <p:txBody>
+          <a:bodyPr/>
+          <a:lstStyle/>
+          <a:p>
+            <a:r>
+              <a:t>METRIC EXPLANATION (Presenter View):</a:t>
+            </a:r>
+          </a:p>
+          <a:p>
+            <a:r>
+              <a:t>• Detection F1 0.89 = balance of recall (catching tumors) &amp; precision (not over-flagging); computed PER-PATIENT to avoid inflation.</a:t>
+            </a:r>
+          </a:p>
+          <a:p>
+            <a:r>
+              <a:t>• Sensitivity 80% = caught 20/25 tumor patients (missed 5) — the most clinically important number (missing a tumor is dangerous).</a:t>
+            </a:r>
+          </a:p>
+          <a:p>
+            <a:r>
+              <a:t>• Localization pIoU 0.27 = box overlap (intersection/union), PENALIZED for extra/missing lesions → moderate, the weaker point (finds the region but not tightly).</a:t>
+            </a:r>
+          </a:p>
+          <a:p>
+            <a:r>
+              <a:t>• recall@IoU.25 54% = 54% of tumors roughly localized (overlap ≥ 0.25).</a:t>
+            </a:r>
+          </a:p>
+          <a:p>
+            <a:r>
+              <a:t>• False-positive 1.5% = on tumor-free slices, rarely invents a box (good).</a:t>
+            </a:r>
+          </a:p>
+          <a:p>
+            <a:r>
+              <a:t>• CI95 [0.19, 0.36] = 95% confidence interval; the number varies because n is small (not a hard value).</a:t>
+            </a:r>
+          </a:p>
+          <a:p>
+            <a:r>
+              <a:t>• No forgetting = thanks to LoRA keeping base weights → still chats / JSON / poem / math.</a:t>
+            </a:r>
+          </a:p>
+          <a:p>
+            <a:r>
+              <a:t>• ~0.27 vs MedRegA ~0.23 = same ballpark despite 5× smaller, DIFFERENT dataset so reference only, NOT a 'we beat them' claim.</a:t>
+            </a:r>
+          </a:p>
+          <a:p>
+            <a:r>
+              <a:t>• Caveat: small n (25 pos / 2 neg), wide CI, a PoC — no clinical claim.</a:t>
+            </a:r>
+          </a:p>
+          <a:p/>
+          <a:p>
+            <a:r>
+              <a:t>SCRIPT (~40s): "Our model reaches F1 0.89 on detection, 80% sensitivity (20/25 patients). Localization pIoU is 0.27 — only moderate, we don't hide it. Pluses: rarely invents tumors (FP 1.5%) and no forgetting thanks to LoRA. Localization is on par with MedRegA despite being 5× smaller, but different data so reference only. This is a PoC, small sample, so statistical limits remain."</a:t>
+            </a:r>
+          </a:p>
+          <a:p/>
+        </p:txBody>
+      </p:sp>
+      <p:sp>
+        <p:nvSpPr>
+          <p:cNvPr id="4" name="Slide Number Placeholder 3"/>
+          <p:cNvSpPr>
+            <a:spLocks noGrp="1"/>
+          </p:cNvSpPr>
+          <p:nvPr>
+            <p:ph type="sldNum" idx="5" sz="quarter"/>
+          </p:nvPr>
+        </p:nvSpPr>
+        <p:spPr/>
+      </p:sp>
+    </p:spTree>
+  </p:cSld>
+  <p:clrMapOvr>
+    <a:masterClrMapping/>
+  </p:clrMapOvr>
+</p:notes>
 </file>
 
 <file path=ppt/slideLayouts/slideLayout1.xml><?xml version="1.0" encoding="utf-8"?>
@@ -6270,4 +6742,324 @@
   </a:objectDefaults>
   <a:extraClrSchemeLst/>
 </a:theme>
+</file>
+
+<file path=ppt/theme/theme2.xml><?xml version="1.0" encoding="utf-8"?>
+<a:theme xmlns:a="http://schemas.openxmlformats.org/drawingml/2006/main" name="Office Theme">
+  <a:themeElements>
+    <a:clrScheme name="Office">
+      <a:dk1>
+        <a:sysClr val="windowText" lastClr="000000"/>
+      </a:dk1>
+      <a:lt1>
+        <a:sysClr val="window" lastClr="FFFFFF"/>
+      </a:lt1>
+      <a:dk2>
+        <a:srgbClr val="1F497D"/>
+      </a:dk2>
+      <a:lt2>
+        <a:srgbClr val="EEECE1"/>
+      </a:lt2>
+      <a:accent1>
+        <a:srgbClr val="4F81BD"/>
+      </a:accent1>
+      <a:accent2>
+        <a:srgbClr val="C0504D"/>
+      </a:accent2>
+      <a:accent3>
+        <a:srgbClr val="9BBB59"/>
+      </a:accent3>
+      <a:accent4>
+        <a:srgbClr val="8064A2"/>
+      </a:accent4>
+      <a:accent5>
+        <a:srgbClr val="4BACC6"/>
+      </a:accent5>
+      <a:accent6>
+        <a:srgbClr val="F79646"/>
+      </a:accent6>
+      <a:hlink>
+        <a:srgbClr val="0000FF"/>
+      </a:hlink>
+      <a:folHlink>
+        <a:srgbClr val="800080"/>
+      </a:folHlink>
+    </a:clrScheme>
+    <a:fontScheme name="Office">
+      <a:majorFont>
+        <a:latin typeface="Calibri"/>
+        <a:ea typeface=""/>
+        <a:cs typeface=""/>
+        <a:font script="Jpan" typeface="ＭＳ Ｐゴシック"/>
+        <a:font script="Hang" typeface="맑은 고딕"/>
+        <a:font script="Hans" typeface="宋体"/>
+        <a:font script="Hant" typeface="新細明體"/>
+        <a:font script="Arab" typeface="Times New Roman"/>
+        <a:font script="Hebr" typeface="Times New Roman"/>
+        <a:font script="Thai" typeface="Angsana New"/>
+        <a:font script="Ethi" typeface="Nyala"/>
+        <a:font script="Beng" typeface="Vrinda"/>
+        <a:font script="Gujr" typeface="Shruti"/>
+        <a:font script="Khmr" typeface="MoolBoran"/>
+        <a:font script="Knda" typeface="Tunga"/>
+        <a:font script="Guru" typeface="Raavi"/>
+        <a:font script="Cans" typeface="Euphemia"/>
+        <a:font script="Cher" typeface="Plantagenet Cherokee"/>
+        <a:font script="Yiii" typeface="Microsoft Yi Baiti"/>
+        <a:font script="Tibt" typeface="Microsoft Himalaya"/>
+        <a:font script="Thaa" typeface="MV Boli"/>
+        <a:font script="Deva" typeface="Mangal"/>
+        <a:font script="Telu" typeface="Gautami"/>
+        <a:font script="Taml" typeface="Latha"/>
+        <a:font script="Syrc" typeface="Estrangelo Edessa"/>
+        <a:font script="Orya" typeface="Kalinga"/>
+        <a:font script="Mlym" typeface="Kartika"/>
+        <a:font script="Laoo" typeface="DokChampa"/>
+        <a:font script="Sinh" typeface="Iskoola Pota"/>
+        <a:font script="Mong" typeface="Mongolian Baiti"/>
+        <a:font script="Viet" typeface="Times New Roman"/>
+        <a:font script="Uigh" typeface="Microsoft Uighur"/>
+        <a:font script="Geor" typeface="Sylfaen"/>
+      </a:majorFont>
+      <a:minorFont>
+        <a:latin typeface="Calibri"/>
+        <a:ea typeface=""/>
+        <a:cs typeface=""/>
+        <a:font script="Jpan" typeface="ＭＳ Ｐゴシック"/>
+        <a:font script="Hang" typeface="맑은 고딕"/>
+        <a:font script="Hans" typeface="宋体"/>
+        <a:font script="Hant" typeface="新細明體"/>
+        <a:font script="Arab" typeface="Arial"/>
+        <a:font script="Hebr" typeface="Arial"/>
+        <a:font script="Thai" typeface="Cordia New"/>
+        <a:font script="Ethi" typeface="Nyala"/>
+        <a:font script="Beng" typeface="Vrinda"/>
+        <a:font script="Gujr" typeface="Shruti"/>
+        <a:font script="Khmr" typeface="DaunPenh"/>
+        <a:font script="Knda" typeface="Tunga"/>
+        <a:font script="Guru" typeface="Raavi"/>
+        <a:font script="Cans" typeface="Euphemia"/>
+        <a:font script="Cher" typeface="Plantagenet Cherokee"/>
+        <a:font script="Yiii" typeface="Microsoft Yi Baiti"/>
+        <a:font script="Tibt" typeface="Microsoft Himalaya"/>
+        <a:font script="Thaa" typeface="MV Boli"/>
+        <a:font script="Deva" typeface="Mangal"/>
+        <a:font script="Telu" typeface="Gautami"/>
+        <a:font script="Taml" typeface="Latha"/>
+        <a:font script="Syrc" typeface="Estrangelo Edessa"/>
+        <a:font script="Orya" typeface="Kalinga"/>
+        <a:font script="Mlym" typeface="Kartika"/>
+        <a:font script="Laoo" typeface="DokChampa"/>
+        <a:font script="Sinh" typeface="Iskoola Pota"/>
+        <a:font script="Mong" typeface="Mongolian Baiti"/>
+        <a:font script="Viet" typeface="Arial"/>
+        <a:font script="Uigh" typeface="Microsoft Uighur"/>
+        <a:font script="Geor" typeface="Sylfaen"/>
+      </a:minorFont>
+    </a:fontScheme>
+    <a:fmtScheme name="Office">
+      <a:fillStyleLst>
+        <a:solidFill>
+          <a:schemeClr val="phClr"/>
+        </a:solidFill>
+        <a:gradFill rotWithShape="1">
+          <a:gsLst>
+            <a:gs pos="0">
+              <a:schemeClr val="phClr">
+                <a:tint val="50000"/>
+                <a:satMod val="300000"/>
+              </a:schemeClr>
+            </a:gs>
+            <a:gs pos="35000">
+              <a:schemeClr val="phClr">
+                <a:tint val="37000"/>
+                <a:satMod val="300000"/>
+              </a:schemeClr>
+            </a:gs>
+            <a:gs pos="100000">
+              <a:schemeClr val="phClr">
+                <a:tint val="15000"/>
+                <a:satMod val="350000"/>
+              </a:schemeClr>
+            </a:gs>
+          </a:gsLst>
+          <a:lin ang="16200000" scaled="1"/>
+        </a:gradFill>
+        <a:gradFill rotWithShape="1">
+          <a:gsLst>
+            <a:gs pos="0">
+              <a:schemeClr val="phClr">
+                <a:tint val="100000"/>
+                <a:shade val="100000"/>
+                <a:satMod val="130000"/>
+              </a:schemeClr>
+            </a:gs>
+            <a:gs pos="100000">
+              <a:schemeClr val="phClr">
+                <a:tint val="50000"/>
+                <a:shade val="100000"/>
+                <a:satMod val="350000"/>
+              </a:schemeClr>
+            </a:gs>
+          </a:gsLst>
+          <a:lin ang="16200000" scaled="0"/>
+        </a:gradFill>
+      </a:fillStyleLst>
+      <a:lnStyleLst>
+        <a:ln w="9525" cap="flat" cmpd="sng" algn="ctr">
+          <a:solidFill>
+            <a:schemeClr val="phClr">
+              <a:shade val="95000"/>
+              <a:satMod val="105000"/>
+            </a:schemeClr>
+          </a:solidFill>
+          <a:prstDash val="solid"/>
+        </a:ln>
+        <a:ln w="25400" cap="flat" cmpd="sng" algn="ctr">
+          <a:solidFill>
+            <a:schemeClr val="phClr"/>
+          </a:solidFill>
+          <a:prstDash val="solid"/>
+        </a:ln>
+        <a:ln w="38100" cap="flat" cmpd="sng" algn="ctr">
+          <a:solidFill>
+            <a:schemeClr val="phClr"/>
+          </a:solidFill>
+          <a:prstDash val="solid"/>
+        </a:ln>
+      </a:lnStyleLst>
+      <a:effectStyleLst>
+        <a:effectStyle>
+          <a:effectLst>
+            <a:outerShdw blurRad="40000" dist="20000" dir="5400000" rotWithShape="0">
+              <a:srgbClr val="000000">
+                <a:alpha val="38000"/>
+              </a:srgbClr>
+            </a:outerShdw>
+          </a:effectLst>
+        </a:effectStyle>
+        <a:effectStyle>
+          <a:effectLst>
+            <a:outerShdw blurRad="40000" dist="23000" dir="5400000" rotWithShape="0">
+              <a:srgbClr val="000000">
+                <a:alpha val="35000"/>
+              </a:srgbClr>
+            </a:outerShdw>
+          </a:effectLst>
+        </a:effectStyle>
+        <a:effectStyle>
+          <a:effectLst>
+            <a:outerShdw blurRad="40000" dist="23000" dir="5400000" rotWithShape="0">
+              <a:srgbClr val="000000">
+                <a:alpha val="35000"/>
+              </a:srgbClr>
+            </a:outerShdw>
+          </a:effectLst>
+          <a:scene3d>
+            <a:camera prst="orthographicFront">
+              <a:rot lat="0" lon="0" rev="0"/>
+            </a:camera>
+            <a:lightRig rig="threePt" dir="t">
+              <a:rot lat="0" lon="0" rev="1200000"/>
+            </a:lightRig>
+          </a:scene3d>
+          <a:sp3d>
+            <a:bevelT w="63500" h="25400"/>
+          </a:sp3d>
+        </a:effectStyle>
+      </a:effectStyleLst>
+      <a:bgFillStyleLst>
+        <a:solidFill>
+          <a:schemeClr val="phClr"/>
+        </a:solidFill>
+        <a:gradFill rotWithShape="1">
+          <a:gsLst>
+            <a:gs pos="0">
+              <a:schemeClr val="phClr">
+                <a:tint val="40000"/>
+                <a:satMod val="350000"/>
+              </a:schemeClr>
+            </a:gs>
+            <a:gs pos="40000">
+              <a:schemeClr val="phClr">
+                <a:tint val="45000"/>
+                <a:shade val="99000"/>
+                <a:satMod val="350000"/>
+              </a:schemeClr>
+            </a:gs>
+            <a:gs pos="100000">
+              <a:schemeClr val="phClr">
+                <a:shade val="20000"/>
+                <a:satMod val="255000"/>
+              </a:schemeClr>
+            </a:gs>
+          </a:gsLst>
+          <a:path path="circle">
+            <a:fillToRect l="50000" t="-80000" r="50000" b="180000"/>
+          </a:path>
+        </a:gradFill>
+        <a:gradFill rotWithShape="1">
+          <a:gsLst>
+            <a:gs pos="0">
+              <a:schemeClr val="phClr">
+                <a:tint val="80000"/>
+                <a:satMod val="300000"/>
+              </a:schemeClr>
+            </a:gs>
+            <a:gs pos="100000">
+              <a:schemeClr val="phClr">
+                <a:shade val="30000"/>
+                <a:satMod val="200000"/>
+              </a:schemeClr>
+            </a:gs>
+          </a:gsLst>
+          <a:path path="circle">
+            <a:fillToRect l="50000" t="50000" r="50000" b="50000"/>
+          </a:path>
+        </a:gradFill>
+      </a:bgFillStyleLst>
+    </a:fmtScheme>
+  </a:themeElements>
+  <a:objectDefaults>
+    <a:spDef>
+      <a:spPr/>
+      <a:bodyPr/>
+      <a:lstStyle/>
+      <a:style>
+        <a:lnRef idx="1">
+          <a:schemeClr val="accent1"/>
+        </a:lnRef>
+        <a:fillRef idx="3">
+          <a:schemeClr val="accent1"/>
+        </a:fillRef>
+        <a:effectRef idx="2">
+          <a:schemeClr val="accent1"/>
+        </a:effectRef>
+        <a:fontRef idx="minor">
+          <a:schemeClr val="lt1"/>
+        </a:fontRef>
+      </a:style>
+    </a:spDef>
+    <a:lnDef>
+      <a:spPr/>
+      <a:bodyPr/>
+      <a:lstStyle/>
+      <a:style>
+        <a:lnRef idx="2">
+          <a:schemeClr val="accent1"/>
+        </a:lnRef>
+        <a:fillRef idx="0">
+          <a:schemeClr val="accent1"/>
+        </a:fillRef>
+        <a:effectRef idx="1">
+          <a:schemeClr val="accent1"/>
+        </a:effectRef>
+        <a:fontRef idx="minor">
+          <a:schemeClr val="tx1"/>
+        </a:fontRef>
+      </a:style>
+    </a:lnDef>
+  </a:objectDefaults>
+  <a:extraClrSchemeLst/>
+</a:theme>
 </file>
</xml_diff>

<commit_message>
cai_tien: deck 5p — hình định tính before/after (S4) + slide 5 thành Hướng tương lai
- S4: thêm hình ca thật (pid14) zero-shot 'No tumor' vs sau fine-tune
  khoanh trúng IoU 0.86 (dựng từ eval, VN+EN).
- S5: đổi từ "Kết luận" lặp -> "Hướng tương lai", 4 hướng gắn hạn chế.

Co-Authored-By: Claude Opus 4.8 <noreply@anthropic.com>
</commit_message>
<xml_diff>
--- a/seminar/cai_tien/slides_5min_EN.pptx
+++ b/seminar/cai_tien/slides_5min_EN.pptx
@@ -5660,7 +5660,7 @@
       </p:sp>
       <p:pic>
         <p:nvPicPr>
-          <p:cNvPr id="6" name="Picture 5" descr="detect_before_after_en.png"/>
+          <p:cNvPr id="6" name="Picture 5" descr="before_after_qual_en.png"/>
           <p:cNvPicPr>
             <a:picLocks noChangeAspect="1"/>
           </p:cNvPicPr>
@@ -5674,8 +5674,8 @@
         </p:blipFill>
         <p:spPr>
           <a:xfrm>
-            <a:off x="5577840" y="1508760"/>
-            <a:ext cx="3383280" cy="1953725"/>
+            <a:off x="5394960" y="1828800"/>
+            <a:ext cx="3611880" cy="2161585"/>
           </a:xfrm>
           <a:prstGeom prst="rect">
             <a:avLst/>
@@ -5690,8 +5690,8 @@
         </p:nvSpPr>
         <p:spPr>
           <a:xfrm>
-            <a:off x="5577840" y="3489916"/>
-            <a:ext cx="3383280" cy="274320"/>
+            <a:off x="5394960" y="4017817"/>
+            <a:ext cx="3611880" cy="274320"/>
           </a:xfrm>
           <a:prstGeom prst="rect">
             <a:avLst/>
@@ -5712,7 +5712,7 @@
                 </a:solidFill>
                 <a:latin typeface="Calibri"/>
               </a:rPr>
-              <a:t>Before → after fine-tune</a:t>
+              <a:t>Same case: before → after fine-tune</a:t>
             </a:r>
           </a:p>
         </p:txBody>
@@ -5951,7 +5951,7 @@
         <p:spPr>
           <a:xfrm>
             <a:off x="0" y="0"/>
-            <a:ext cx="9144000" cy="886968"/>
+            <a:ext cx="9144000" cy="1188720"/>
           </a:xfrm>
           <a:prstGeom prst="rect">
             <a:avLst/>
@@ -5994,7 +5994,7 @@
         </p:nvSpPr>
         <p:spPr>
           <a:xfrm>
-            <a:off x="320040" y="182880"/>
+            <a:off x="320040" y="109728"/>
             <a:ext cx="8503920" cy="548640"/>
           </a:xfrm>
           <a:prstGeom prst="rect">
@@ -6015,7 +6015,7 @@
                 </a:solidFill>
                 <a:latin typeface="Cambria"/>
               </a:rPr>
-              <a:t>Conclusion</a:t>
+              <a:t>Future work</a:t>
             </a:r>
           </a:p>
         </p:txBody>
@@ -6028,8 +6028,42 @@
         </p:nvSpPr>
         <p:spPr>
           <a:xfrm>
-            <a:off x="365760" y="1115568"/>
-            <a:ext cx="8412480" cy="2743200"/>
+            <a:off x="338328" y="694944"/>
+            <a:ext cx="8412480" cy="411480"/>
+          </a:xfrm>
+          <a:prstGeom prst="rect">
+            <a:avLst/>
+          </a:prstGeom>
+          <a:noFill/>
+        </p:spPr>
+        <p:txBody>
+          <a:bodyPr wrap="square" anchor="t" lIns="25400" rIns="25400" tIns="12700" bIns="12700">
+            <a:spAutoFit/>
+          </a:bodyPr>
+          <a:lstStyle/>
+          <a:p>
+            <a:r>
+              <a:rPr sz="1150" b="0" i="1">
+                <a:solidFill>
+                  <a:srgbClr val="B8CFE0"/>
+                </a:solidFill>
+                <a:latin typeface="Calibri"/>
+              </a:rPr>
+              <a:t>Each direction targets a limitation we observed</a:t>
+            </a:r>
+          </a:p>
+        </p:txBody>
+      </p:sp>
+      <p:sp>
+        <p:nvSpPr>
+          <p:cNvPr id="5" name="TextBox 4"/>
+          <p:cNvSpPr txBox="1"/>
+          <p:nvPr/>
+        </p:nvSpPr>
+        <p:spPr>
+          <a:xfrm>
+            <a:off x="365760" y="1463039"/>
+            <a:ext cx="8412480" cy="2651760"/>
           </a:xfrm>
           <a:prstGeom prst="rect">
             <a:avLst/>
@@ -6047,11 +6081,11 @@
                 <a:spcPts val="0"/>
               </a:spcBef>
               <a:spcAft>
-                <a:spcPts val="1300"/>
+                <a:spcPts val="1200"/>
               </a:spcAft>
             </a:pPr>
             <a:r>
-              <a:rPr sz="1500" b="1" i="0">
+              <a:rPr sz="1350" b="1" i="0">
                 <a:solidFill>
                   <a:srgbClr val="1A3A5C"/>
                 </a:solidFill>
@@ -6060,40 +6094,49 @@
               <a:t>▪  </a:t>
             </a:r>
             <a:r>
-              <a:rPr sz="1500" b="1" i="0">
+              <a:rPr sz="1350" b="0" i="0">
                 <a:solidFill>
                   <a:srgbClr val="1C2736"/>
                 </a:solidFill>
                 <a:latin typeface="Calibri"/>
               </a:rPr>
-              <a:t>Proof of mechanism:</a:t>
-            </a:r>
-            <a:r>
-              <a:rPr sz="1500" b="0" i="0">
+              <a:t>Missed isointense tumors (wide CT window) → </a:t>
+            </a:r>
+            <a:r>
+              <a:rPr sz="1350" b="1" i="0">
                 <a:solidFill>
                   <a:srgbClr val="1C2736"/>
                 </a:solidFill>
                 <a:latin typeface="Calibri"/>
               </a:rPr>
-              <a:t> region-centric (localize-then-read) is feasible at </a:t>
-            </a:r>
-            <a:r>
-              <a:rPr sz="1500" b="1" i="0">
+              <a:t>multi-window</a:t>
+            </a:r>
+            <a:r>
+              <a:rPr sz="1350" b="0" i="0">
                 <a:solidFill>
                   <a:srgbClr val="1C2736"/>
                 </a:solidFill>
                 <a:latin typeface="Calibri"/>
               </a:rPr>
-              <a:t>~8B, 1 GPU</a:t>
-            </a:r>
-            <a:r>
-              <a:rPr sz="1500" b="0" i="0">
+              <a:t> (narrow liver window) + </a:t>
+            </a:r>
+            <a:r>
+              <a:rPr sz="1350" b="1" i="0">
                 <a:solidFill>
                   <a:srgbClr val="1C2736"/>
                 </a:solidFill>
                 <a:latin typeface="Calibri"/>
               </a:rPr>
-              <a:t>.</a:t>
+              <a:t>2.5D</a:t>
+            </a:r>
+            <a:r>
+              <a:rPr sz="1350" b="0" i="0">
+                <a:solidFill>
+                  <a:srgbClr val="1C2736"/>
+                </a:solidFill>
+                <a:latin typeface="Calibri"/>
+              </a:rPr>
+              <a:t> to restore 3D context.</a:t>
             </a:r>
           </a:p>
           <a:p>
@@ -6102,11 +6145,11 @@
                 <a:spcPts val="0"/>
               </a:spcBef>
               <a:spcAft>
-                <a:spcPts val="1300"/>
+                <a:spcPts val="1200"/>
               </a:spcAft>
             </a:pPr>
             <a:r>
-              <a:rPr sz="1500" b="1" i="0">
+              <a:rPr sz="1350" b="1" i="0">
                 <a:solidFill>
                   <a:srgbClr val="1A3A5C"/>
                 </a:solidFill>
@@ -6115,22 +6158,49 @@
               <a:t>▪  </a:t>
             </a:r>
             <a:r>
-              <a:rPr sz="1500" b="1" i="0">
+              <a:rPr sz="1350" b="0" i="0">
                 <a:solidFill>
                   <a:srgbClr val="1C2736"/>
                 </a:solidFill>
                 <a:latin typeface="Calibri"/>
               </a:rPr>
-              <a:t>Value:</a:t>
-            </a:r>
-            <a:r>
-              <a:rPr sz="1500" b="0" i="0">
+              <a:t>Coarse localization (pIoU 0.27) → a dedicated segmenter (</a:t>
+            </a:r>
+            <a:r>
+              <a:rPr sz="1350" b="1" i="0">
                 <a:solidFill>
                   <a:srgbClr val="1C2736"/>
                 </a:solidFill>
                 <a:latin typeface="Calibri"/>
               </a:rPr>
-              <a:t> honest evaluation + selective prediction — not the score.</a:t>
+              <a:t>MedSAM</a:t>
+            </a:r>
+            <a:r>
+              <a:rPr sz="1350" b="0" i="0">
+                <a:solidFill>
+                  <a:srgbClr val="1C2736"/>
+                </a:solidFill>
+                <a:latin typeface="Calibri"/>
+              </a:rPr>
+              <a:t>) or </a:t>
+            </a:r>
+            <a:r>
+              <a:rPr sz="1350" b="1" i="0">
+                <a:solidFill>
+                  <a:srgbClr val="1C2736"/>
+                </a:solidFill>
+                <a:latin typeface="Calibri"/>
+              </a:rPr>
+              <a:t>polygon</a:t>
+            </a:r>
+            <a:r>
+              <a:rPr sz="1350" b="0" i="0">
+                <a:solidFill>
+                  <a:srgbClr val="1C2736"/>
+                </a:solidFill>
+                <a:latin typeface="Calibri"/>
+              </a:rPr>
+              <a:t> for tighter boxes.</a:t>
             </a:r>
           </a:p>
           <a:p>
@@ -6139,11 +6209,11 @@
                 <a:spcPts val="0"/>
               </a:spcBef>
               <a:spcAft>
-                <a:spcPts val="1300"/>
+                <a:spcPts val="1200"/>
               </a:spcAft>
             </a:pPr>
             <a:r>
-              <a:rPr sz="1500" b="1" i="0">
+              <a:rPr sz="1350" b="1" i="0">
                 <a:solidFill>
                   <a:srgbClr val="1A3A5C"/>
                 </a:solidFill>
@@ -6152,22 +6222,49 @@
               <a:t>▪  </a:t>
             </a:r>
             <a:r>
-              <a:rPr sz="1500" b="1" i="0">
+              <a:rPr sz="1350" b="0" i="0">
                 <a:solidFill>
                   <a:srgbClr val="1C2736"/>
                 </a:solidFill>
                 <a:latin typeface="Calibri"/>
               </a:rPr>
-              <a:t>Honest:</a:t>
-            </a:r>
-            <a:r>
-              <a:rPr sz="1500" b="0" i="0">
+              <a:t>Small sample, single dataset → </a:t>
+            </a:r>
+            <a:r>
+              <a:rPr sz="1350" b="1" i="0">
                 <a:solidFill>
                   <a:srgbClr val="1C2736"/>
                 </a:solidFill>
                 <a:latin typeface="Calibri"/>
               </a:rPr>
-              <a:t> PoC on 1 dataset / 1 task, small n, wide CI.</a:t>
+              <a:t>external validation</a:t>
+            </a:r>
+            <a:r>
+              <a:rPr sz="1350" b="0" i="0">
+                <a:solidFill>
+                  <a:srgbClr val="1C2736"/>
+                </a:solidFill>
+                <a:latin typeface="Calibri"/>
+              </a:rPr>
+              <a:t> + </a:t>
+            </a:r>
+            <a:r>
+              <a:rPr sz="1350" b="1" i="0">
+                <a:solidFill>
+                  <a:srgbClr val="1C2736"/>
+                </a:solidFill>
+                <a:latin typeface="Calibri"/>
+              </a:rPr>
+              <a:t>calibration</a:t>
+            </a:r>
+            <a:r>
+              <a:rPr sz="1350" b="0" i="0">
+                <a:solidFill>
+                  <a:srgbClr val="1C2736"/>
+                </a:solidFill>
+                <a:latin typeface="Calibri"/>
+              </a:rPr>
+              <a:t> for reliability.</a:t>
             </a:r>
           </a:p>
           <a:p>
@@ -6176,11 +6273,11 @@
                 <a:spcPts val="0"/>
               </a:spcBef>
               <a:spcAft>
-                <a:spcPts val="1300"/>
+                <a:spcPts val="1200"/>
               </a:spcAft>
             </a:pPr>
             <a:r>
-              <a:rPr sz="1500" b="1" i="0">
+              <a:rPr sz="1350" b="1" i="0">
                 <a:solidFill>
                   <a:srgbClr val="1A3A5C"/>
                 </a:solidFill>
@@ -6189,35 +6286,62 @@
               <a:t>▪  </a:t>
             </a:r>
             <a:r>
-              <a:rPr sz="1500" b="1" i="0">
+              <a:rPr sz="1350" b="0" i="0">
                 <a:solidFill>
                   <a:srgbClr val="1C2736"/>
                 </a:solidFill>
                 <a:latin typeface="Calibri"/>
               </a:rPr>
-              <a:t>Future:</a:t>
-            </a:r>
-            <a:r>
-              <a:rPr sz="1500" b="0" i="0">
+              <a:t>Detection only for now → </a:t>
+            </a:r>
+            <a:r>
+              <a:rPr sz="1350" b="1" i="0">
                 <a:solidFill>
                   <a:srgbClr val="1C2736"/>
                 </a:solidFill>
                 <a:latin typeface="Calibri"/>
               </a:rPr>
-              <a:t> richer images (multi-window, 2.5D) + external validation.</a:t>
-            </a:r>
-          </a:p>
-        </p:txBody>
-      </p:sp>
-      <p:sp>
-        <p:nvSpPr>
-          <p:cNvPr id="5" name="Rectangle 4"/>
+              <a:t>grounded report</a:t>
+            </a:r>
+            <a:r>
+              <a:rPr sz="1350" b="0" i="0">
+                <a:solidFill>
+                  <a:srgbClr val="1C2736"/>
+                </a:solidFill>
+                <a:latin typeface="Calibri"/>
+              </a:rPr>
+              <a:t> (evidence-linked) and </a:t>
+            </a:r>
+            <a:r>
+              <a:rPr sz="1350" b="1" i="0">
+                <a:solidFill>
+                  <a:srgbClr val="1C2736"/>
+                </a:solidFill>
+                <a:latin typeface="Calibri"/>
+              </a:rPr>
+              <a:t>multi-organ</a:t>
+            </a:r>
+            <a:r>
+              <a:rPr sz="1350" b="0" i="0">
+                <a:solidFill>
+                  <a:srgbClr val="1C2736"/>
+                </a:solidFill>
+                <a:latin typeface="Calibri"/>
+              </a:rPr>
+              <a:t> extension.</a:t>
+            </a:r>
+          </a:p>
+        </p:txBody>
+      </p:sp>
+      <p:sp>
+        <p:nvSpPr>
+          <p:cNvPr id="6" name="Rectangle 5"/>
           <p:cNvSpPr/>
           <p:nvPr/>
         </p:nvSpPr>
         <p:spPr>
           <a:xfrm>
-            <a:off x="365760" y="3813048"/>
+            <a:off x="365760" y="4114800"/>
             <a:ext cx="8412480" cy="548640"/>
           </a:xfrm>
           <a:prstGeom prst="rect">
@@ -6255,13 +6379,13 @@
       </p:sp>
       <p:sp>
         <p:nvSpPr>
-          <p:cNvPr id="6" name="TextBox 5"/>
+          <p:cNvPr id="7" name="TextBox 6"/>
           <p:cNvSpPr txBox="1"/>
           <p:nvPr/>
         </p:nvSpPr>
         <p:spPr>
           <a:xfrm>
-            <a:off x="475488" y="3877056"/>
+            <a:off x="475488" y="4178808"/>
             <a:ext cx="8193023" cy="420623"/>
           </a:xfrm>
           <a:prstGeom prst="rect">
@@ -6298,14 +6422,14 @@
                 </a:solidFill>
                 <a:latin typeface="Calibri"/>
               </a:rPr>
-              <a:t>We don't claim to have arrived — we map the road and say where it's still steep.</a:t>
-            </a:r>
-          </a:p>
-        </p:txBody>
-      </p:sp>
-      <p:sp>
-        <p:nvSpPr>
-          <p:cNvPr id="7" name="Rectangle 6"/>
+              <a:t>We don't claim to have arrived — we map the road and where it's still steep.</a:t>
+            </a:r>
+          </a:p>
+        </p:txBody>
+      </p:sp>
+      <p:sp>
+        <p:nvSpPr>
+          <p:cNvPr id="8" name="Rectangle 7"/>
           <p:cNvSpPr/>
           <p:nvPr/>
         </p:nvSpPr>
@@ -6349,7 +6473,7 @@
       </p:sp>
       <p:sp>
         <p:nvSpPr>
-          <p:cNvPr id="8" name="TextBox 7"/>
+          <p:cNvPr id="9" name="TextBox 8"/>
           <p:cNvSpPr txBox="1"/>
           <p:nvPr/>
         </p:nvSpPr>
@@ -6383,7 +6507,7 @@
       </p:sp>
       <p:sp>
         <p:nvSpPr>
-          <p:cNvPr id="9" name="TextBox 8"/>
+          <p:cNvPr id="10" name="TextBox 9"/>
           <p:cNvSpPr txBox="1"/>
           <p:nvPr/>
         </p:nvSpPr>

</xml_diff>

<commit_message>
cai_tien: deck 5p — slide Hướng tương lai theo 4 ý người dùng + ý kỹ thuật
4 hướng: mở rộng task y khoa (grounded report) · đưa lại thông tin 3D
(2.5D + CT đa pha tách u/mạch) · tri thức y khoa tiếng Việt · tăng
dữ liệu (+ external validation + calibration).

Co-Authored-By: Claude Opus 4.8 <noreply@anthropic.com>
</commit_message>
<xml_diff>
--- a/seminar/cai_tien/slides_5min_EN.pptx
+++ b/seminar/cai_tien/slides_5min_EN.pptx
@@ -6063,7 +6063,7 @@
         <p:spPr>
           <a:xfrm>
             <a:off x="365760" y="1463039"/>
-            <a:ext cx="8412480" cy="2651760"/>
+            <a:ext cx="8412480" cy="2743200"/>
           </a:xfrm>
           <a:prstGeom prst="rect">
             <a:avLst/>
@@ -6081,11 +6081,11 @@
                 <a:spcPts val="0"/>
               </a:spcBef>
               <a:spcAft>
-                <a:spcPts val="1200"/>
+                <a:spcPts val="1100"/>
               </a:spcAft>
             </a:pPr>
             <a:r>
-              <a:rPr sz="1350" b="1" i="0">
+              <a:rPr sz="1300" b="1" i="0">
                 <a:solidFill>
                   <a:srgbClr val="1A3A5C"/>
                 </a:solidFill>
@@ -6094,49 +6094,40 @@
               <a:t>▪  </a:t>
             </a:r>
             <a:r>
-              <a:rPr sz="1350" b="0" i="0">
+              <a:rPr sz="1300" b="1" i="0">
                 <a:solidFill>
                   <a:srgbClr val="1C2736"/>
                 </a:solidFill>
                 <a:latin typeface="Calibri"/>
               </a:rPr>
-              <a:t>Missed isointense tumors (wide CT window) → </a:t>
-            </a:r>
-            <a:r>
-              <a:rPr sz="1350" b="1" i="0">
+              <a:t>Broaden scope:</a:t>
+            </a:r>
+            <a:r>
+              <a:rPr sz="1300" b="0" i="0">
                 <a:solidFill>
                   <a:srgbClr val="1C2736"/>
                 </a:solidFill>
                 <a:latin typeface="Calibri"/>
               </a:rPr>
-              <a:t>multi-window</a:t>
-            </a:r>
-            <a:r>
-              <a:rPr sz="1350" b="0" i="0">
+              <a:t> train on other medical tasks (multiple organs, more diseases); toward </a:t>
+            </a:r>
+            <a:r>
+              <a:rPr sz="1300" b="1" i="0">
                 <a:solidFill>
                   <a:srgbClr val="1C2736"/>
                 </a:solidFill>
                 <a:latin typeface="Calibri"/>
               </a:rPr>
-              <a:t> (narrow liver window) + </a:t>
-            </a:r>
-            <a:r>
-              <a:rPr sz="1350" b="1" i="0">
+              <a:t>grounded reporting</a:t>
+            </a:r>
+            <a:r>
+              <a:rPr sz="1300" b="0" i="0">
                 <a:solidFill>
                   <a:srgbClr val="1C2736"/>
                 </a:solidFill>
                 <a:latin typeface="Calibri"/>
               </a:rPr>
-              <a:t>2.5D</a:t>
-            </a:r>
-            <a:r>
-              <a:rPr sz="1350" b="0" i="0">
-                <a:solidFill>
-                  <a:srgbClr val="1C2736"/>
-                </a:solidFill>
-                <a:latin typeface="Calibri"/>
-              </a:rPr>
-              <a:t> to restore 3D context.</a:t>
+              <a:t>.</a:t>
             </a:r>
           </a:p>
           <a:p>
@@ -6145,11 +6136,11 @@
                 <a:spcPts val="0"/>
               </a:spcBef>
               <a:spcAft>
-                <a:spcPts val="1200"/>
+                <a:spcPts val="1100"/>
               </a:spcAft>
             </a:pPr>
             <a:r>
-              <a:rPr sz="1350" b="1" i="0">
+              <a:rPr sz="1300" b="1" i="0">
                 <a:solidFill>
                   <a:srgbClr val="1A3A5C"/>
                 </a:solidFill>
@@ -6158,49 +6149,58 @@
               <a:t>▪  </a:t>
             </a:r>
             <a:r>
-              <a:rPr sz="1350" b="0" i="0">
+              <a:rPr sz="1300" b="1" i="0">
                 <a:solidFill>
                   <a:srgbClr val="1C2736"/>
                 </a:solidFill>
                 <a:latin typeface="Calibri"/>
               </a:rPr>
-              <a:t>Coarse localization (pIoU 0.27) → a dedicated segmenter (</a:t>
-            </a:r>
-            <a:r>
-              <a:rPr sz="1350" b="1" i="0">
+              <a:t>Restore 3D context:</a:t>
+            </a:r>
+            <a:r>
+              <a:rPr sz="1300" b="0" i="0">
                 <a:solidFill>
                   <a:srgbClr val="1C2736"/>
                 </a:solidFill>
                 <a:latin typeface="Calibri"/>
               </a:rPr>
-              <a:t>MedSAM</a:t>
-            </a:r>
-            <a:r>
-              <a:rPr sz="1350" b="0" i="0">
+              <a:t> 3D→2D loses context, hard to separate tumor from vessels (unlike radiologists) → </a:t>
+            </a:r>
+            <a:r>
+              <a:rPr sz="1300" b="1" i="0">
                 <a:solidFill>
                   <a:srgbClr val="1C2736"/>
                 </a:solidFill>
                 <a:latin typeface="Calibri"/>
               </a:rPr>
-              <a:t>) or </a:t>
-            </a:r>
-            <a:r>
-              <a:rPr sz="1350" b="1" i="0">
+              <a:t>stack consecutive slices (2.5D)</a:t>
+            </a:r>
+            <a:r>
+              <a:rPr sz="1300" b="0" i="0">
                 <a:solidFill>
                   <a:srgbClr val="1C2736"/>
                 </a:solidFill>
                 <a:latin typeface="Calibri"/>
               </a:rPr>
-              <a:t>polygon</a:t>
-            </a:r>
-            <a:r>
-              <a:rPr sz="1350" b="0" i="0">
+              <a:t>; further: </a:t>
+            </a:r>
+            <a:r>
+              <a:rPr sz="1300" b="1" i="0">
                 <a:solidFill>
                   <a:srgbClr val="1C2736"/>
                 </a:solidFill>
                 <a:latin typeface="Calibri"/>
               </a:rPr>
-              <a:t> for tighter boxes.</a:t>
+              <a:t>multi-phase CT</a:t>
+            </a:r>
+            <a:r>
+              <a:rPr sz="1300" b="0" i="0">
+                <a:solidFill>
+                  <a:srgbClr val="1C2736"/>
+                </a:solidFill>
+                <a:latin typeface="Calibri"/>
+              </a:rPr>
+              <a:t> via contrast dynamics.</a:t>
             </a:r>
           </a:p>
           <a:p>
@@ -6209,11 +6209,11 @@
                 <a:spcPts val="0"/>
               </a:spcBef>
               <a:spcAft>
-                <a:spcPts val="1200"/>
+                <a:spcPts val="1100"/>
               </a:spcAft>
             </a:pPr>
             <a:r>
-              <a:rPr sz="1350" b="1" i="0">
+              <a:rPr sz="1300" b="1" i="0">
                 <a:solidFill>
                   <a:srgbClr val="1A3A5C"/>
                 </a:solidFill>
@@ -6222,49 +6222,22 @@
               <a:t>▪  </a:t>
             </a:r>
             <a:r>
-              <a:rPr sz="1350" b="0" i="0">
+              <a:rPr sz="1300" b="1" i="0">
                 <a:solidFill>
                   <a:srgbClr val="1C2736"/>
                 </a:solidFill>
                 <a:latin typeface="Calibri"/>
               </a:rPr>
-              <a:t>Small sample, single dataset → </a:t>
-            </a:r>
-            <a:r>
-              <a:rPr sz="1350" b="1" i="0">
+              <a:t>Add Vietnamese medical knowledge:</a:t>
+            </a:r>
+            <a:r>
+              <a:rPr sz="1300" b="0" i="0">
                 <a:solidFill>
                   <a:srgbClr val="1C2736"/>
                 </a:solidFill>
                 <a:latin typeface="Calibri"/>
               </a:rPr>
-              <a:t>external validation</a:t>
-            </a:r>
-            <a:r>
-              <a:rPr sz="1350" b="0" i="0">
-                <a:solidFill>
-                  <a:srgbClr val="1C2736"/>
-                </a:solidFill>
-                <a:latin typeface="Calibri"/>
-              </a:rPr>
-              <a:t> + </a:t>
-            </a:r>
-            <a:r>
-              <a:rPr sz="1350" b="1" i="0">
-                <a:solidFill>
-                  <a:srgbClr val="1C2736"/>
-                </a:solidFill>
-                <a:latin typeface="Calibri"/>
-              </a:rPr>
-              <a:t>calibration</a:t>
-            </a:r>
-            <a:r>
-              <a:rPr sz="1350" b="0" i="0">
-                <a:solidFill>
-                  <a:srgbClr val="1C2736"/>
-                </a:solidFill>
-                <a:latin typeface="Calibri"/>
-              </a:rPr>
-              <a:t> for reliability.</a:t>
+              <a:t> train on more Vietnamese data (many niche domain terms) for correct Vietnamese-context answers.</a:t>
             </a:r>
           </a:p>
           <a:p>
@@ -6273,11 +6246,11 @@
                 <a:spcPts val="0"/>
               </a:spcBef>
               <a:spcAft>
-                <a:spcPts val="1200"/>
+                <a:spcPts val="1100"/>
               </a:spcAft>
             </a:pPr>
             <a:r>
-              <a:rPr sz="1350" b="1" i="0">
+              <a:rPr sz="1300" b="1" i="0">
                 <a:solidFill>
                   <a:srgbClr val="1A3A5C"/>
                 </a:solidFill>
@@ -6286,49 +6259,58 @@
               <a:t>▪  </a:t>
             </a:r>
             <a:r>
-              <a:rPr sz="1350" b="0" i="0">
+              <a:rPr sz="1300" b="1" i="0">
                 <a:solidFill>
                   <a:srgbClr val="1C2736"/>
                 </a:solidFill>
                 <a:latin typeface="Calibri"/>
               </a:rPr>
-              <a:t>Detection only for now → </a:t>
-            </a:r>
-            <a:r>
-              <a:rPr sz="1350" b="1" i="0">
+              <a:t>More training data:</a:t>
+            </a:r>
+            <a:r>
+              <a:rPr sz="1300" b="0" i="0">
                 <a:solidFill>
                   <a:srgbClr val="1C2736"/>
                 </a:solidFill>
                 <a:latin typeface="Calibri"/>
               </a:rPr>
-              <a:t>grounded report</a:t>
-            </a:r>
-            <a:r>
-              <a:rPr sz="1350" b="0" i="0">
+              <a:t> current data is limited so evaluation n is too small to trust → more data + </a:t>
+            </a:r>
+            <a:r>
+              <a:rPr sz="1300" b="1" i="0">
                 <a:solidFill>
                   <a:srgbClr val="1C2736"/>
                 </a:solidFill>
                 <a:latin typeface="Calibri"/>
               </a:rPr>
-              <a:t> (evidence-linked) and </a:t>
-            </a:r>
-            <a:r>
-              <a:rPr sz="1350" b="1" i="0">
+              <a:t>external validation</a:t>
+            </a:r>
+            <a:r>
+              <a:rPr sz="1300" b="0" i="0">
                 <a:solidFill>
                   <a:srgbClr val="1C2736"/>
                 </a:solidFill>
                 <a:latin typeface="Calibri"/>
               </a:rPr>
-              <a:t>multi-organ</a:t>
-            </a:r>
-            <a:r>
-              <a:rPr sz="1350" b="0" i="0">
+              <a:t> + </a:t>
+            </a:r>
+            <a:r>
+              <a:rPr sz="1300" b="1" i="0">
                 <a:solidFill>
                   <a:srgbClr val="1C2736"/>
                 </a:solidFill>
                 <a:latin typeface="Calibri"/>
               </a:rPr>
-              <a:t> extension.</a:t>
+              <a:t>calibration</a:t>
+            </a:r>
+            <a:r>
+              <a:rPr sz="1300" b="0" i="0">
+                <a:solidFill>
+                  <a:srgbClr val="1C2736"/>
+                </a:solidFill>
+                <a:latin typeface="Calibri"/>
+              </a:rPr>
+              <a:t>.</a:t>
             </a:r>
           </a:p>
         </p:txBody>

</xml_diff>

<commit_message>
cai_tien: deck 5p — câu Tổng kết chuẩn văn báo cáo (bỏ 'không hứa đã tới đích')
Co-Authored-By: Claude Opus 4.8 <noreply@anthropic.com>
</commit_message>
<xml_diff>
--- a/seminar/cai_tien/slides_5min_EN.pptx
+++ b/seminar/cai_tien/slides_5min_EN.pptx
@@ -6323,8 +6323,8 @@
         </p:nvSpPr>
         <p:spPr>
           <a:xfrm>
-            <a:off x="365760" y="4114800"/>
-            <a:ext cx="8412480" cy="548640"/>
+            <a:off x="365760" y="4069080"/>
+            <a:ext cx="8412480" cy="713232"/>
           </a:xfrm>
           <a:prstGeom prst="rect">
             <a:avLst/>
@@ -6367,8 +6367,8 @@
         </p:nvSpPr>
         <p:spPr>
           <a:xfrm>
-            <a:off x="475488" y="4178808"/>
-            <a:ext cx="8193023" cy="420623"/>
+            <a:off x="475488" y="4133088"/>
+            <a:ext cx="8193023" cy="585216"/>
           </a:xfrm>
           <a:prstGeom prst="rect">
             <a:avLst/>
@@ -6388,7 +6388,7 @@
                 </a:solidFill>
                 <a:latin typeface="Calibri"/>
               </a:rPr>
-              <a:t>Closing</a:t>
+              <a:t>Summary</a:t>
             </a:r>
           </a:p>
           <a:p>
@@ -6404,7 +6404,7 @@
                 </a:solidFill>
                 <a:latin typeface="Calibri"/>
               </a:rPr>
-              <a:t>We don't claim to have arrived — we map the road and where it's still steep.</a:t>
+              <a:t>This work demonstrates the feasibility of a region-centric approach at small scale (proof-of-concept); the directions above aim to address current limitations and move toward practical application.</a:t>
             </a:r>
           </a:p>
         </p:txBody>

</xml_diff>

<commit_message>
cai_tien: hình before/after — box ĐỎ + ô phóng to vùng u cho dễ nhìn
Co-Authored-By: Claude Opus 4.8 <noreply@anthropic.com>
</commit_message>
<xml_diff>
--- a/seminar/cai_tien/slides_5min_EN.pptx
+++ b/seminar/cai_tien/slides_5min_EN.pptx
@@ -5675,7 +5675,7 @@
         <p:spPr>
           <a:xfrm>
             <a:off x="5394960" y="1828800"/>
-            <a:ext cx="3611880" cy="2161585"/>
+            <a:ext cx="3611880" cy="2190963"/>
           </a:xfrm>
           <a:prstGeom prst="rect">
             <a:avLst/>
@@ -5690,7 +5690,7 @@
         </p:nvSpPr>
         <p:spPr>
           <a:xfrm>
-            <a:off x="5394960" y="4017817"/>
+            <a:off x="5394960" y="4047195"/>
             <a:ext cx="3611880" cy="274320"/>
           </a:xfrm>
           <a:prstGeom prst="rect">

</xml_diff>

<commit_message>
cai_tien: deck 5p — câu Lưu ý S3 thành câu văn dễ đọc (bỏ n/bn/CI/PoC viết tắt)
Co-Authored-By: Claude Opus 4.8 <noreply@anthropic.com>
</commit_message>
<xml_diff>
--- a/seminar/cai_tien/slides_5min_EN.pptx
+++ b/seminar/cai_tien/slides_5min_EN.pptx
@@ -5105,8 +5105,8 @@
         </p:nvSpPr>
         <p:spPr>
           <a:xfrm>
-            <a:off x="365760" y="4178808"/>
-            <a:ext cx="8412480" cy="548640"/>
+            <a:off x="365760" y="4087368"/>
+            <a:ext cx="8412480" cy="658368"/>
           </a:xfrm>
           <a:prstGeom prst="rect">
             <a:avLst/>
@@ -5149,8 +5149,8 @@
         </p:nvSpPr>
         <p:spPr>
           <a:xfrm>
-            <a:off x="475488" y="4242816"/>
-            <a:ext cx="8193023" cy="420623"/>
+            <a:off x="475488" y="4151376"/>
+            <a:ext cx="8193023" cy="530352"/>
           </a:xfrm>
           <a:prstGeom prst="rect">
             <a:avLst/>
@@ -5186,7 +5186,7 @@
                 </a:solidFill>
                 <a:latin typeface="Calibri"/>
               </a:rPr>
-              <a:t>small n (~25 pos patients / 2 neg) → wide CI; a PoC, no clinical claim.</a:t>
+              <a:t>The test set is small — about 25 tumor patients and 2 without — so the numbers still vary; this is a proof-of-concept, not a clinical system.</a:t>
             </a:r>
           </a:p>
         </p:txBody>

</xml_diff>

<commit_message>
cai_tien: deck 5p EN — sync các sửa từ VN (box-fix S2, IoU matched S3, notes)
Bản tiếng Anh giờ khớp bản VN: bỏ 'coarse box', dòng IoU matched
~0.32 vs 0.23 (penalized stricter), speaker notes Q&A về matched-only.

Co-Authored-By: Claude Opus 4.8 <noreply@anthropic.com>
</commit_message>
<xml_diff>
--- a/seminar/cai_tien/slides_5min_EN.pptx
+++ b/seminar/cai_tien/slides_5min_EN.pptx
@@ -546,7 +546,7 @@
           </a:p>
           <a:p>
             <a:r>
-              <a:t>• ~0.27 vs MedRegA ~0.23 = same ballpark despite 5× smaller, DIFFERENT dataset so reference only, NOT a 'we beat them' claim.</a:t>
+              <a:t>• vs MedRegA (Q&amp;A): their IoU 0.23 is MATCHED-ONLY (no miss penalty — Algorithm 1 Hungarian) on mostly LARGE structures + LOOSE boxes ("need not be tight", paper). Same matched basis: ours ~0.32 &gt; 0.23. Our pIoU 0.27 is PENALIZED, stricter. Don't claim "we win" (different dataset). Don't say "they merge one box" — they are multi-box too (Figure 8).</a:t>
             </a:r>
           </a:p>
           <a:p>
@@ -4150,7 +4150,7 @@
                           </a:solidFill>
                           <a:latin typeface="Calibri"/>
                         </a:rPr>
-                        <a:t>, coarse box</a:t>
+                        <a:t> → can't measure invented boxes</a:t>
                       </a:r>
                     </a:p>
                   </a:txBody>
@@ -4172,7 +4172,7 @@
                           </a:solidFill>
                           <a:latin typeface="Calibri"/>
                         </a:rPr>
-                        <a:t>Multi-slice + negatives + multi-box</a:t>
+                        <a:t>Multi-slice + negatives</a:t>
                       </a:r>
                       <a:r>
                         <a:rPr sz="1150" b="0" i="0">
@@ -4181,7 +4181,7 @@
                           </a:solidFill>
                           <a:latin typeface="Calibri"/>
                         </a:rPr>
-                        <a:t> (per-lesion); split by patient</a:t>
+                        <a:t> (measures false-positives); tight per-lesion boxes, split by patient</a:t>
                       </a:r>
                     </a:p>
                   </a:txBody>
@@ -5074,7 +5074,7 @@
                 </a:solidFill>
                 <a:latin typeface="Calibri"/>
               </a:rPr>
-              <a:t>Localization ~0.27 ≈ </a:t>
+              <a:t>Localization on the same (matched) basis: </a:t>
             </a:r>
             <a:r>
               <a:rPr sz="1250" b="1" i="0">
@@ -5083,7 +5083,7 @@
                 </a:solidFill>
                 <a:latin typeface="Calibri"/>
               </a:rPr>
-              <a:t>same ballpark as MedRegA (~0.23)</a:t>
+              <a:t>~0.32 vs MedRegA ~0.23</a:t>
             </a:r>
             <a:r>
               <a:rPr sz="1250" b="0" i="0">
@@ -5092,7 +5092,25 @@
                 </a:solidFill>
                 <a:latin typeface="Calibri"/>
               </a:rPr>
-              <a:t> despite 5× smaller — different dataset, reference only.</a:t>
+              <a:t>; our </a:t>
+            </a:r>
+            <a:r>
+              <a:rPr sz="1250" b="1" i="0">
+                <a:solidFill>
+                  <a:srgbClr val="1C2736"/>
+                </a:solidFill>
+                <a:latin typeface="Calibri"/>
+              </a:rPr>
+              <a:t>penalized</a:t>
+            </a:r>
+            <a:r>
+              <a:rPr sz="1250" b="0" i="0">
+                <a:solidFill>
+                  <a:srgbClr val="1C2736"/>
+                </a:solidFill>
+                <a:latin typeface="Calibri"/>
+              </a:rPr>
+              <a:t> pIoU (0.27) is stricter still — their targets are larger with looser boxes, different dataset.</a:t>
             </a:r>
           </a:p>
         </p:txBody>

</xml_diff>